<commit_message>
Add detailed process flow diagrams for Dispute Resolution stages 2-5
Builds out slides 4-7 (Case Preparation & Document Assessment, Provisional
Credit Issuance, Network Submission & Response, Resolution & Recovery) to
match the visual style and format of slide 3's Dispute Initiation & Triage
diagram, using a single path per stage per direction. Network Submission &
Response incorporates the Visa dispute/chargeback SLA timeframes (120/75,
30, 10 days) from slide 8.

Co-Authored-By: Claude Sonnet 5 <noreply@anthropic.com>
Claude-Session: https://claude.ai/code/session_01Msiz5p6hoKmmUHZyLJTkqb
</commit_message>
<xml_diff>
--- a/Dispute Resolution/Dispute Resolution Process Flow.pptx
+++ b/Dispute Resolution/Dispute Resolution Process Flow.pptx
@@ -17284,6 +17284,1015 @@
           </a:graphicData>
         </a:graphic>
       </p:graphicFrame>
+      <p:sp>
+        <p:nvSpPr>
+          <p:cNvPr id="973" name="Rounded Rectangle 972"/>
+          <p:cNvSpPr/>
+          <p:nvPr/>
+        </p:nvSpPr>
+        <p:spPr>
+          <a:xfrm>
+            <a:off x="460000" y="2500000"/>
+            <a:ext cx="1260000" cy="720000"/>
+          </a:xfrm>
+          <a:prstGeom prst="roundRect">
+            <a:avLst>
+              <a:gd name="adj" fmla="val 10000"/>
+            </a:avLst>
+          </a:prstGeom>
+          <a:noFill/>
+          <a:ln w="12700">
+            <a:solidFill>
+              <a:srgbClr val="BFBFBF"/>
+            </a:solidFill>
+          </a:ln>
+          <a:effectLst/>
+        </p:spPr>
+        <p:style>
+          <a:lnRef idx="1">
+            <a:schemeClr val="accent1"/>
+          </a:lnRef>
+          <a:fillRef idx="3">
+            <a:schemeClr val="accent1"/>
+          </a:fillRef>
+          <a:effectRef idx="2">
+            <a:schemeClr val="accent1"/>
+          </a:effectRef>
+          <a:fontRef idx="minor">
+            <a:schemeClr val="lt1"/>
+          </a:fontRef>
+        </p:style>
+        <p:txBody>
+          <a:bodyPr rtlCol="0" anchor="ctr" wrap="square" lIns="45720" rIns="45720" tIns="36576" bIns="36576"/>
+          <a:lstStyle/>
+          <a:p>
+            <a:pPr algn="ctr"/>
+            <a:r>
+              <a:rPr sz="900" b="1" i="0">
+                <a:solidFill>
+                  <a:srgbClr val="404040"/>
+                </a:solidFill>
+                <a:latin typeface="Segoe UI"/>
+              </a:rPr>
+              <a:t>Receive case from Stage 1</a:t>
+            </a:r>
+          </a:p>
+        </p:txBody>
+      </p:sp>
+      <p:sp>
+        <p:nvSpPr>
+          <p:cNvPr id="974" name="Rounded Rectangle 973"/>
+          <p:cNvSpPr/>
+          <p:nvPr/>
+        </p:nvSpPr>
+        <p:spPr>
+          <a:xfrm>
+            <a:off x="2110000" y="2500000"/>
+            <a:ext cx="1260000" cy="720000"/>
+          </a:xfrm>
+          <a:prstGeom prst="roundRect">
+            <a:avLst>
+              <a:gd name="adj" fmla="val 10000"/>
+            </a:avLst>
+          </a:prstGeom>
+          <a:noFill/>
+          <a:ln w="12700">
+            <a:solidFill>
+              <a:srgbClr val="BFBFBF"/>
+            </a:solidFill>
+          </a:ln>
+          <a:effectLst/>
+        </p:spPr>
+        <p:style>
+          <a:lnRef idx="1">
+            <a:schemeClr val="accent1"/>
+          </a:lnRef>
+          <a:fillRef idx="3">
+            <a:schemeClr val="accent1"/>
+          </a:fillRef>
+          <a:effectRef idx="2">
+            <a:schemeClr val="accent1"/>
+          </a:effectRef>
+          <a:fontRef idx="minor">
+            <a:schemeClr val="lt1"/>
+          </a:fontRef>
+        </p:style>
+        <p:txBody>
+          <a:bodyPr rtlCol="0" anchor="ctr" wrap="square" lIns="45720" rIns="45720" tIns="36576" bIns="36576"/>
+          <a:lstStyle/>
+          <a:p>
+            <a:pPr algn="ctr"/>
+            <a:r>
+              <a:rPr sz="900" b="1" i="0">
+                <a:solidFill>
+                  <a:srgbClr val="404040"/>
+                </a:solidFill>
+                <a:latin typeface="Segoe UI"/>
+              </a:rPr>
+              <a:t>Review cardholder statement &amp; transaction data</a:t>
+            </a:r>
+          </a:p>
+        </p:txBody>
+      </p:sp>
+      <p:sp>
+        <p:nvSpPr>
+          <p:cNvPr id="975" name="Diamond 974"/>
+          <p:cNvSpPr/>
+          <p:nvPr/>
+        </p:nvSpPr>
+        <p:spPr>
+          <a:xfrm>
+            <a:off x="3760000" y="2425660"/>
+            <a:ext cx="1296000" cy="868680"/>
+          </a:xfrm>
+          <a:prstGeom prst="diamond">
+            <a:avLst/>
+          </a:prstGeom>
+          <a:solidFill>
+            <a:srgbClr val="FFFFFF"/>
+          </a:solidFill>
+          <a:ln w="12700">
+            <a:solidFill>
+              <a:srgbClr val="BFBFBF"/>
+            </a:solidFill>
+          </a:ln>
+          <a:effectLst/>
+        </p:spPr>
+        <p:style>
+          <a:lnRef idx="1">
+            <a:schemeClr val="accent1"/>
+          </a:lnRef>
+          <a:fillRef idx="3">
+            <a:schemeClr val="accent1"/>
+          </a:fillRef>
+          <a:effectRef idx="2">
+            <a:schemeClr val="accent1"/>
+          </a:effectRef>
+          <a:fontRef idx="minor">
+            <a:schemeClr val="lt1"/>
+          </a:fontRef>
+        </p:style>
+        <p:txBody>
+          <a:bodyPr rtlCol="0" anchor="ctr" wrap="square" lIns="0" rIns="0" tIns="36576" bIns="36576"/>
+          <a:lstStyle/>
+          <a:p>
+            <a:pPr algn="ctr"/>
+            <a:r>
+              <a:rPr sz="900" b="1" i="0">
+                <a:solidFill>
+                  <a:srgbClr val="404040"/>
+                </a:solidFill>
+                <a:latin typeface="Segoe UI"/>
+              </a:rPr>
+              <a:t>Evidence needed?</a:t>
+            </a:r>
+          </a:p>
+        </p:txBody>
+      </p:sp>
+      <p:sp>
+        <p:nvSpPr>
+          <p:cNvPr id="976" name="Rounded Rectangle 975"/>
+          <p:cNvSpPr/>
+          <p:nvPr/>
+        </p:nvSpPr>
+        <p:spPr>
+          <a:xfrm>
+            <a:off x="5580000" y="2500000"/>
+            <a:ext cx="1260000" cy="720000"/>
+          </a:xfrm>
+          <a:prstGeom prst="roundRect">
+            <a:avLst>
+              <a:gd name="adj" fmla="val 10000"/>
+            </a:avLst>
+          </a:prstGeom>
+          <a:noFill/>
+          <a:ln w="12700">
+            <a:solidFill>
+              <a:srgbClr val="BFBFBF"/>
+            </a:solidFill>
+          </a:ln>
+          <a:effectLst/>
+        </p:spPr>
+        <p:style>
+          <a:lnRef idx="1">
+            <a:schemeClr val="accent1"/>
+          </a:lnRef>
+          <a:fillRef idx="3">
+            <a:schemeClr val="accent1"/>
+          </a:fillRef>
+          <a:effectRef idx="2">
+            <a:schemeClr val="accent1"/>
+          </a:effectRef>
+          <a:fontRef idx="minor">
+            <a:schemeClr val="lt1"/>
+          </a:fontRef>
+        </p:style>
+        <p:txBody>
+          <a:bodyPr rtlCol="0" anchor="ctr" wrap="square" lIns="45720" rIns="45720" tIns="36576" bIns="36576"/>
+          <a:lstStyle/>
+          <a:p>
+            <a:pPr algn="ctr"/>
+            <a:r>
+              <a:rPr sz="900" b="1" i="0">
+                <a:solidFill>
+                  <a:srgbClr val="404040"/>
+                </a:solidFill>
+                <a:latin typeface="Segoe UI"/>
+              </a:rPr>
+              <a:t>Validate dispute eligibility &amp; assign reason code</a:t>
+            </a:r>
+          </a:p>
+        </p:txBody>
+      </p:sp>
+      <p:sp>
+        <p:nvSpPr>
+          <p:cNvPr id="977" name="Diamond 976"/>
+          <p:cNvSpPr/>
+          <p:nvPr/>
+        </p:nvSpPr>
+        <p:spPr>
+          <a:xfrm>
+            <a:off x="7400000" y="2425660"/>
+            <a:ext cx="1296000" cy="868680"/>
+          </a:xfrm>
+          <a:prstGeom prst="diamond">
+            <a:avLst/>
+          </a:prstGeom>
+          <a:solidFill>
+            <a:srgbClr val="FFFFFF"/>
+          </a:solidFill>
+          <a:ln w="12700">
+            <a:solidFill>
+              <a:srgbClr val="BFBFBF"/>
+            </a:solidFill>
+          </a:ln>
+          <a:effectLst/>
+        </p:spPr>
+        <p:style>
+          <a:lnRef idx="1">
+            <a:schemeClr val="accent1"/>
+          </a:lnRef>
+          <a:fillRef idx="3">
+            <a:schemeClr val="accent1"/>
+          </a:fillRef>
+          <a:effectRef idx="2">
+            <a:schemeClr val="accent1"/>
+          </a:effectRef>
+          <a:fontRef idx="minor">
+            <a:schemeClr val="lt1"/>
+          </a:fontRef>
+        </p:style>
+        <p:txBody>
+          <a:bodyPr rtlCol="0" anchor="ctr" wrap="square" lIns="0" rIns="0" tIns="36576" bIns="36576"/>
+          <a:lstStyle/>
+          <a:p>
+            <a:pPr algn="ctr"/>
+            <a:r>
+              <a:rPr sz="900" b="1" i="0">
+                <a:solidFill>
+                  <a:srgbClr val="404040"/>
+                </a:solidFill>
+                <a:latin typeface="Segoe UI"/>
+              </a:rPr>
+              <a:t>Eligible under reason code?</a:t>
+            </a:r>
+          </a:p>
+        </p:txBody>
+      </p:sp>
+      <p:sp>
+        <p:nvSpPr>
+          <p:cNvPr id="978" name="Rounded Rectangle 977"/>
+          <p:cNvSpPr/>
+          <p:nvPr/>
+        </p:nvSpPr>
+        <p:spPr>
+          <a:xfrm>
+            <a:off x="9400000" y="2500000"/>
+            <a:ext cx="1260000" cy="720000"/>
+          </a:xfrm>
+          <a:prstGeom prst="roundRect">
+            <a:avLst>
+              <a:gd name="adj" fmla="val 10000"/>
+            </a:avLst>
+          </a:prstGeom>
+          <a:noFill/>
+          <a:ln w="12700">
+            <a:solidFill>
+              <a:srgbClr val="BFBFBF"/>
+            </a:solidFill>
+          </a:ln>
+          <a:effectLst/>
+        </p:spPr>
+        <p:style>
+          <a:lnRef idx="1">
+            <a:schemeClr val="accent1"/>
+          </a:lnRef>
+          <a:fillRef idx="3">
+            <a:schemeClr val="accent1"/>
+          </a:fillRef>
+          <a:effectRef idx="2">
+            <a:schemeClr val="accent1"/>
+          </a:effectRef>
+          <a:fontRef idx="minor">
+            <a:schemeClr val="lt1"/>
+          </a:fontRef>
+        </p:style>
+        <p:txBody>
+          <a:bodyPr rtlCol="0" anchor="ctr" wrap="square" lIns="45720" rIns="45720" tIns="36576" bIns="36576"/>
+          <a:lstStyle/>
+          <a:p>
+            <a:pPr algn="ctr"/>
+            <a:r>
+              <a:rPr sz="900" b="1" i="0">
+                <a:solidFill>
+                  <a:srgbClr val="404040"/>
+                </a:solidFill>
+                <a:latin typeface="Segoe UI"/>
+              </a:rPr>
+              <a:t>Assess potential liability &amp; recovery options</a:t>
+            </a:r>
+          </a:p>
+        </p:txBody>
+      </p:sp>
+      <p:sp>
+        <p:nvSpPr>
+          <p:cNvPr id="979" name="Rounded Rectangle 978"/>
+          <p:cNvSpPr/>
+          <p:nvPr/>
+        </p:nvSpPr>
+        <p:spPr>
+          <a:xfrm>
+            <a:off x="3660000" y="4000000"/>
+            <a:ext cx="1260000" cy="720000"/>
+          </a:xfrm>
+          <a:prstGeom prst="roundRect">
+            <a:avLst>
+              <a:gd name="adj" fmla="val 10000"/>
+            </a:avLst>
+          </a:prstGeom>
+          <a:solidFill>
+            <a:srgbClr val="EDDBFB">
+              <a:alpha val="56863"/>
+            </a:srgbClr>
+          </a:solidFill>
+          <a:ln w="12700">
+            <a:solidFill>
+              <a:srgbClr val="9B40EA"/>
+            </a:solidFill>
+          </a:ln>
+          <a:effectLst/>
+        </p:spPr>
+        <p:style>
+          <a:lnRef idx="1">
+            <a:schemeClr val="accent1"/>
+          </a:lnRef>
+          <a:fillRef idx="3">
+            <a:schemeClr val="accent1"/>
+          </a:fillRef>
+          <a:effectRef idx="2">
+            <a:schemeClr val="accent1"/>
+          </a:effectRef>
+          <a:fontRef idx="minor">
+            <a:schemeClr val="lt1"/>
+          </a:fontRef>
+        </p:style>
+        <p:txBody>
+          <a:bodyPr rtlCol="0" anchor="ctr" wrap="square" lIns="45720" rIns="45720" tIns="36576" bIns="36576"/>
+          <a:lstStyle/>
+          <a:p>
+            <a:pPr algn="ctr"/>
+            <a:r>
+              <a:rPr sz="900" b="1" i="0">
+                <a:solidFill>
+                  <a:srgbClr val="404040"/>
+                </a:solidFill>
+                <a:latin typeface="Segoe UI"/>
+              </a:rPr>
+              <a:t>Request missing info &amp; evidence from cardholder</a:t>
+            </a:r>
+          </a:p>
+        </p:txBody>
+      </p:sp>
+      <p:sp>
+        <p:nvSpPr>
+          <p:cNvPr id="980" name="Oval 979"/>
+          <p:cNvSpPr/>
+          <p:nvPr/>
+        </p:nvSpPr>
+        <p:spPr>
+          <a:xfrm>
+            <a:off x="7904000" y="4060000"/>
+            <a:ext cx="288000" cy="288000"/>
+          </a:xfrm>
+          <a:prstGeom prst="ellipse">
+            <a:avLst/>
+          </a:prstGeom>
+          <a:solidFill>
+            <a:srgbClr val="BFBFBF"/>
+          </a:solidFill>
+          <a:ln>
+            <a:noFill/>
+          </a:ln>
+          <a:effectLst/>
+        </p:spPr>
+        <p:style>
+          <a:lnRef idx="1">
+            <a:schemeClr val="accent1"/>
+          </a:lnRef>
+          <a:fillRef idx="3">
+            <a:schemeClr val="accent1"/>
+          </a:fillRef>
+          <a:effectRef idx="2">
+            <a:schemeClr val="accent1"/>
+          </a:effectRef>
+          <a:fontRef idx="minor">
+            <a:schemeClr val="lt1"/>
+          </a:fontRef>
+        </p:style>
+        <p:txBody>
+          <a:bodyPr rtlCol="0" anchor="ctr"/>
+          <a:lstStyle/>
+          <a:p>
+            <a:pPr algn="ctr"/>
+          </a:p>
+        </p:txBody>
+      </p:sp>
+      <p:sp>
+        <p:nvSpPr>
+          <p:cNvPr id="981" name="TextBox 980"/>
+          <p:cNvSpPr txBox="1"/>
+          <p:nvPr/>
+        </p:nvSpPr>
+        <p:spPr>
+          <a:xfrm>
+            <a:off x="8284000" y="4010000"/>
+            <a:ext cx="1700000" cy="430000"/>
+          </a:xfrm>
+          <a:prstGeom prst="rect">
+            <a:avLst/>
+          </a:prstGeom>
+          <a:noFill/>
+        </p:spPr>
+        <p:txBody>
+          <a:bodyPr wrap="square" lIns="45720" rIns="45720" tIns="36576" bIns="36576" anchor="ctr">
+            <a:spAutoFit/>
+          </a:bodyPr>
+          <a:lstStyle/>
+          <a:p>
+            <a:pPr algn="ctr"/>
+            <a:r>
+              <a:rPr sz="900" b="1" i="0">
+                <a:solidFill>
+                  <a:srgbClr val="404040"/>
+                </a:solidFill>
+                <a:latin typeface="Segoe UI"/>
+              </a:rPr>
+              <a:t>Not eligible; deny and
+communicate to cardholder</a:t>
+            </a:r>
+          </a:p>
+        </p:txBody>
+      </p:sp>
+      <p:grpSp>
+        <p:nvGrpSpPr>
+          <p:cNvPr id="9001" name="Handoff"/>
+          <p:cNvGrpSpPr/>
+          <p:nvPr/>
+        </p:nvGrpSpPr>
+        <p:grpSpPr>
+          <a:xfrm>
+            <a:off x="10960000" y="2734000"/>
+            <a:ext cx="252000" cy="252000"/>
+            <a:chOff x="10960000" y="2734000"/>
+            <a:chExt cx="252000" cy="252000"/>
+          </a:xfrm>
+        </p:grpSpPr>
+        <p:sp>
+          <p:nvSpPr>
+            <p:cNvPr id="9002" name="hoffc"/>
+            <p:cNvSpPr/>
+            <p:nvPr/>
+          </p:nvSpPr>
+          <p:spPr>
+            <a:xfrm>
+              <a:off x="10960000" y="2734000"/>
+              <a:ext cx="252000" cy="252000"/>
+            </a:xfrm>
+            <a:prstGeom prst="ellipse">
+              <a:avLst/>
+            </a:prstGeom>
+            <a:solidFill>
+              <a:srgbClr val="9DD4CF"/>
+            </a:solidFill>
+            <a:ln>
+              <a:noFill/>
+            </a:ln>
+          </p:spPr>
+          <p:txBody>
+            <a:bodyPr/>
+            <a:lstStyle/>
+            <a:p>
+              <a:endParaRPr lang="en-US"/>
+            </a:p>
+          </p:txBody>
+        </p:sp>
+        <p:sp>
+          <p:nvSpPr>
+            <p:cNvPr id="9003" name="hoffa"/>
+            <p:cNvSpPr/>
+            <p:nvPr/>
+          </p:nvSpPr>
+          <p:spPr>
+            <a:xfrm>
+              <a:off x="11010316" y="2797821"/>
+              <a:ext cx="161665" cy="124358"/>
+            </a:xfrm>
+            <a:prstGeom prst="rightArrow">
+              <a:avLst>
+                <a:gd name="adj1" fmla="val 50000"/>
+                <a:gd name="adj2" fmla="val 50000"/>
+              </a:avLst>
+            </a:prstGeom>
+            <a:solidFill>
+              <a:srgbClr val="FFFFFF"/>
+            </a:solidFill>
+            <a:ln>
+              <a:noFill/>
+            </a:ln>
+          </p:spPr>
+          <p:txBody>
+            <a:bodyPr/>
+            <a:lstStyle/>
+            <a:p>
+              <a:endParaRPr lang="en-US"/>
+            </a:p>
+          </p:txBody>
+        </p:sp>
+      </p:grpSp>
+      <p:cxnSp>
+        <p:nvCxnSpPr>
+          <p:cNvPr id="9004" name="Connector 9003"/>
+          <p:cNvCxnSpPr/>
+          <p:nvPr/>
+        </p:nvCxnSpPr>
+        <p:spPr>
+          <a:xfrm>
+            <a:off x="1720000" y="2860000"/>
+            <a:ext cx="390000" cy="0"/>
+          </a:xfrm>
+          <a:prstGeom prst="line">
+            <a:avLst/>
+          </a:prstGeom>
+          <a:ln w="19050">
+            <a:solidFill>
+              <a:srgbClr val="9B9B9B"/>
+            </a:solidFill>
+            <a:tailEnd type="triangle" w="med" len="med"/>
+          </a:ln>
+        </p:spPr>
+        <p:style>
+          <a:lnRef idx="2">
+            <a:schemeClr val="accent1"/>
+          </a:lnRef>
+          <a:fillRef idx="0">
+            <a:schemeClr val="accent1"/>
+          </a:fillRef>
+          <a:effectRef idx="1">
+            <a:schemeClr val="accent1"/>
+          </a:effectRef>
+          <a:fontRef idx="minor">
+            <a:schemeClr val="tx1"/>
+          </a:fontRef>
+        </p:style>
+      </p:cxnSp>
+      <p:cxnSp>
+        <p:nvCxnSpPr>
+          <p:cNvPr id="9005" name="Connector 9004"/>
+          <p:cNvCxnSpPr/>
+          <p:nvPr/>
+        </p:nvCxnSpPr>
+        <p:spPr>
+          <a:xfrm>
+            <a:off x="3370000" y="2860000"/>
+            <a:ext cx="390000" cy="0"/>
+          </a:xfrm>
+          <a:prstGeom prst="line">
+            <a:avLst/>
+          </a:prstGeom>
+          <a:ln w="19050">
+            <a:solidFill>
+              <a:srgbClr val="9B9B9B"/>
+            </a:solidFill>
+            <a:tailEnd type="triangle" w="med" len="med"/>
+          </a:ln>
+        </p:spPr>
+        <p:style>
+          <a:lnRef idx="2">
+            <a:schemeClr val="accent1"/>
+          </a:lnRef>
+          <a:fillRef idx="0">
+            <a:schemeClr val="accent1"/>
+          </a:fillRef>
+          <a:effectRef idx="1">
+            <a:schemeClr val="accent1"/>
+          </a:effectRef>
+          <a:fontRef idx="minor">
+            <a:schemeClr val="tx1"/>
+          </a:fontRef>
+        </p:style>
+      </p:cxnSp>
+      <p:cxnSp>
+        <p:nvCxnSpPr>
+          <p:cNvPr id="9006" name="Connector 9005"/>
+          <p:cNvCxnSpPr/>
+          <p:nvPr/>
+        </p:nvCxnSpPr>
+        <p:spPr>
+          <a:xfrm flipH="1">
+            <a:off x="4290000" y="3294340"/>
+            <a:ext cx="118000" cy="705660"/>
+          </a:xfrm>
+          <a:prstGeom prst="bentConnector3">
+            <a:avLst/>
+          </a:prstGeom>
+          <a:ln w="19050">
+            <a:solidFill>
+              <a:srgbClr val="9B9B9B"/>
+            </a:solidFill>
+            <a:tailEnd type="triangle" w="med" len="med"/>
+          </a:ln>
+        </p:spPr>
+        <p:style>
+          <a:lnRef idx="2">
+            <a:schemeClr val="accent1"/>
+          </a:lnRef>
+          <a:fillRef idx="0">
+            <a:schemeClr val="accent1"/>
+          </a:fillRef>
+          <a:effectRef idx="1">
+            <a:schemeClr val="accent1"/>
+          </a:effectRef>
+          <a:fontRef idx="minor">
+            <a:schemeClr val="tx1"/>
+          </a:fontRef>
+        </p:style>
+      </p:cxnSp>
+      <p:sp>
+        <p:nvSpPr>
+          <p:cNvPr id="9007" name="TextBox 9006"/>
+          <p:cNvSpPr txBox="1"/>
+          <p:nvPr/>
+        </p:nvSpPr>
+        <p:spPr>
+          <a:xfrm>
+            <a:off x="4448000" y="3324340"/>
+            <a:ext cx="620000" cy="260000"/>
+          </a:xfrm>
+          <a:prstGeom prst="rect">
+            <a:avLst/>
+          </a:prstGeom>
+          <a:noFill/>
+        </p:spPr>
+        <p:txBody>
+          <a:bodyPr wrap="square" lIns="45720" rIns="45720" tIns="36576" bIns="36576" anchor="ctr">
+            <a:spAutoFit/>
+          </a:bodyPr>
+          <a:lstStyle/>
+          <a:p>
+            <a:pPr algn="ctr"/>
+            <a:r>
+              <a:rPr sz="900" b="1" i="0">
+                <a:solidFill>
+                  <a:srgbClr val="009A44"/>
+                </a:solidFill>
+                <a:latin typeface="Segoe UI"/>
+              </a:rPr>
+              <a:t>Yes</a:t>
+            </a:r>
+          </a:p>
+        </p:txBody>
+      </p:sp>
+      <p:cxnSp>
+        <p:nvCxnSpPr>
+          <p:cNvPr id="9008" name="Connector 9007"/>
+          <p:cNvCxnSpPr/>
+          <p:nvPr/>
+        </p:nvCxnSpPr>
+        <p:spPr>
+          <a:xfrm>
+            <a:off x="5056000" y="2860000"/>
+            <a:ext cx="524000" cy="0"/>
+          </a:xfrm>
+          <a:prstGeom prst="line">
+            <a:avLst/>
+          </a:prstGeom>
+          <a:ln w="19050">
+            <a:solidFill>
+              <a:srgbClr val="9B9B9B"/>
+            </a:solidFill>
+            <a:tailEnd type="triangle" w="med" len="med"/>
+          </a:ln>
+        </p:spPr>
+        <p:style>
+          <a:lnRef idx="2">
+            <a:schemeClr val="accent1"/>
+          </a:lnRef>
+          <a:fillRef idx="0">
+            <a:schemeClr val="accent1"/>
+          </a:fillRef>
+          <a:effectRef idx="1">
+            <a:schemeClr val="accent1"/>
+          </a:effectRef>
+          <a:fontRef idx="minor">
+            <a:schemeClr val="tx1"/>
+          </a:fontRef>
+        </p:style>
+      </p:cxnSp>
+      <p:sp>
+        <p:nvSpPr>
+          <p:cNvPr id="9009" name="TextBox 9008"/>
+          <p:cNvSpPr txBox="1"/>
+          <p:nvPr/>
+        </p:nvSpPr>
+        <p:spPr>
+          <a:xfrm>
+            <a:off x="5096000" y="2580000"/>
+            <a:ext cx="620000" cy="260000"/>
+          </a:xfrm>
+          <a:prstGeom prst="rect">
+            <a:avLst/>
+          </a:prstGeom>
+          <a:noFill/>
+        </p:spPr>
+        <p:txBody>
+          <a:bodyPr wrap="square" lIns="45720" rIns="45720" tIns="36576" bIns="36576" anchor="ctr">
+            <a:spAutoFit/>
+          </a:bodyPr>
+          <a:lstStyle/>
+          <a:p>
+            <a:pPr algn="ctr"/>
+            <a:r>
+              <a:rPr sz="900" b="1" i="0">
+                <a:solidFill>
+                  <a:srgbClr val="C00000"/>
+                </a:solidFill>
+                <a:latin typeface="Segoe UI"/>
+              </a:rPr>
+              <a:t>No</a:t>
+            </a:r>
+          </a:p>
+        </p:txBody>
+      </p:sp>
+      <p:cxnSp>
+        <p:nvCxnSpPr>
+          <p:cNvPr id="9010" name="Connector 9009"/>
+          <p:cNvCxnSpPr/>
+          <p:nvPr/>
+        </p:nvCxnSpPr>
+        <p:spPr>
+          <a:xfrm flipV="1">
+            <a:off x="4920000" y="2860000"/>
+            <a:ext cx="660000" cy="1500000"/>
+          </a:xfrm>
+          <a:prstGeom prst="bentConnector3">
+            <a:avLst/>
+          </a:prstGeom>
+          <a:ln w="19050">
+            <a:solidFill>
+              <a:srgbClr val="9B9B9B"/>
+            </a:solidFill>
+            <a:tailEnd type="triangle" w="med" len="med"/>
+          </a:ln>
+        </p:spPr>
+        <p:style>
+          <a:lnRef idx="2">
+            <a:schemeClr val="accent1"/>
+          </a:lnRef>
+          <a:fillRef idx="0">
+            <a:schemeClr val="accent1"/>
+          </a:fillRef>
+          <a:effectRef idx="1">
+            <a:schemeClr val="accent1"/>
+          </a:effectRef>
+          <a:fontRef idx="minor">
+            <a:schemeClr val="tx1"/>
+          </a:fontRef>
+        </p:style>
+      </p:cxnSp>
+      <p:cxnSp>
+        <p:nvCxnSpPr>
+          <p:cNvPr id="9011" name="Connector 9010"/>
+          <p:cNvCxnSpPr/>
+          <p:nvPr/>
+        </p:nvCxnSpPr>
+        <p:spPr>
+          <a:xfrm>
+            <a:off x="6840000" y="2860000"/>
+            <a:ext cx="560000" cy="0"/>
+          </a:xfrm>
+          <a:prstGeom prst="line">
+            <a:avLst/>
+          </a:prstGeom>
+          <a:ln w="19050">
+            <a:solidFill>
+              <a:srgbClr val="9B9B9B"/>
+            </a:solidFill>
+            <a:tailEnd type="triangle" w="med" len="med"/>
+          </a:ln>
+        </p:spPr>
+        <p:style>
+          <a:lnRef idx="2">
+            <a:schemeClr val="accent1"/>
+          </a:lnRef>
+          <a:fillRef idx="0">
+            <a:schemeClr val="accent1"/>
+          </a:fillRef>
+          <a:effectRef idx="1">
+            <a:schemeClr val="accent1"/>
+          </a:effectRef>
+          <a:fontRef idx="minor">
+            <a:schemeClr val="tx1"/>
+          </a:fontRef>
+        </p:style>
+      </p:cxnSp>
+      <p:cxnSp>
+        <p:nvCxnSpPr>
+          <p:cNvPr id="9012" name="Connector 9011"/>
+          <p:cNvCxnSpPr/>
+          <p:nvPr/>
+        </p:nvCxnSpPr>
+        <p:spPr>
+          <a:xfrm>
+            <a:off x="8696000" y="2860000"/>
+            <a:ext cx="704000" cy="0"/>
+          </a:xfrm>
+          <a:prstGeom prst="line">
+            <a:avLst/>
+          </a:prstGeom>
+          <a:ln w="19050">
+            <a:solidFill>
+              <a:srgbClr val="9B9B9B"/>
+            </a:solidFill>
+            <a:tailEnd type="triangle" w="med" len="med"/>
+          </a:ln>
+        </p:spPr>
+        <p:style>
+          <a:lnRef idx="2">
+            <a:schemeClr val="accent1"/>
+          </a:lnRef>
+          <a:fillRef idx="0">
+            <a:schemeClr val="accent1"/>
+          </a:fillRef>
+          <a:effectRef idx="1">
+            <a:schemeClr val="accent1"/>
+          </a:effectRef>
+          <a:fontRef idx="minor">
+            <a:schemeClr val="tx1"/>
+          </a:fontRef>
+        </p:style>
+      </p:cxnSp>
+      <p:sp>
+        <p:nvSpPr>
+          <p:cNvPr id="9013" name="TextBox 9012"/>
+          <p:cNvSpPr txBox="1"/>
+          <p:nvPr/>
+        </p:nvSpPr>
+        <p:spPr>
+          <a:xfrm>
+            <a:off x="8798000" y="2580000"/>
+            <a:ext cx="620000" cy="260000"/>
+          </a:xfrm>
+          <a:prstGeom prst="rect">
+            <a:avLst/>
+          </a:prstGeom>
+          <a:noFill/>
+        </p:spPr>
+        <p:txBody>
+          <a:bodyPr wrap="square" lIns="45720" rIns="45720" tIns="36576" bIns="36576" anchor="ctr">
+            <a:spAutoFit/>
+          </a:bodyPr>
+          <a:lstStyle/>
+          <a:p>
+            <a:pPr algn="ctr"/>
+            <a:r>
+              <a:rPr sz="900" b="1" i="0">
+                <a:solidFill>
+                  <a:srgbClr val="009A44"/>
+                </a:solidFill>
+                <a:latin typeface="Segoe UI"/>
+              </a:rPr>
+              <a:t>Yes</a:t>
+            </a:r>
+          </a:p>
+        </p:txBody>
+      </p:sp>
+      <p:cxnSp>
+        <p:nvCxnSpPr>
+          <p:cNvPr id="9014" name="Connector 9013"/>
+          <p:cNvCxnSpPr/>
+          <p:nvPr/>
+        </p:nvCxnSpPr>
+        <p:spPr>
+          <a:xfrm>
+            <a:off x="8048000" y="3294340"/>
+            <a:ext cx="0" cy="765660"/>
+          </a:xfrm>
+          <a:prstGeom prst="bentConnector3">
+            <a:avLst/>
+          </a:prstGeom>
+          <a:ln w="19050">
+            <a:solidFill>
+              <a:srgbClr val="9B9B9B"/>
+            </a:solidFill>
+            <a:tailEnd type="triangle" w="med" len="med"/>
+          </a:ln>
+        </p:spPr>
+        <p:style>
+          <a:lnRef idx="2">
+            <a:schemeClr val="accent1"/>
+          </a:lnRef>
+          <a:fillRef idx="0">
+            <a:schemeClr val="accent1"/>
+          </a:fillRef>
+          <a:effectRef idx="1">
+            <a:schemeClr val="accent1"/>
+          </a:effectRef>
+          <a:fontRef idx="minor">
+            <a:schemeClr val="tx1"/>
+          </a:fontRef>
+        </p:style>
+      </p:cxnSp>
+      <p:sp>
+        <p:nvSpPr>
+          <p:cNvPr id="9015" name="TextBox 9014"/>
+          <p:cNvSpPr txBox="1"/>
+          <p:nvPr/>
+        </p:nvSpPr>
+        <p:spPr>
+          <a:xfrm>
+            <a:off x="8088000" y="3324340"/>
+            <a:ext cx="620000" cy="260000"/>
+          </a:xfrm>
+          <a:prstGeom prst="rect">
+            <a:avLst/>
+          </a:prstGeom>
+          <a:noFill/>
+        </p:spPr>
+        <p:txBody>
+          <a:bodyPr wrap="square" lIns="45720" rIns="45720" tIns="36576" bIns="36576" anchor="ctr">
+            <a:spAutoFit/>
+          </a:bodyPr>
+          <a:lstStyle/>
+          <a:p>
+            <a:pPr algn="ctr"/>
+            <a:r>
+              <a:rPr sz="900" b="1" i="0">
+                <a:solidFill>
+                  <a:srgbClr val="C00000"/>
+                </a:solidFill>
+                <a:latin typeface="Segoe UI"/>
+              </a:rPr>
+              <a:t>No</a:t>
+            </a:r>
+          </a:p>
+        </p:txBody>
+      </p:sp>
+      <p:cxnSp>
+        <p:nvCxnSpPr>
+          <p:cNvPr id="9016" name="Connector 9015"/>
+          <p:cNvCxnSpPr/>
+          <p:nvPr/>
+        </p:nvCxnSpPr>
+        <p:spPr>
+          <a:xfrm>
+            <a:off x="10660000" y="2860000"/>
+            <a:ext cx="300000" cy="0"/>
+          </a:xfrm>
+          <a:prstGeom prst="line">
+            <a:avLst/>
+          </a:prstGeom>
+          <a:ln w="19050">
+            <a:solidFill>
+              <a:srgbClr val="9B9B9B"/>
+            </a:solidFill>
+            <a:tailEnd type="triangle" w="med" len="med"/>
+          </a:ln>
+        </p:spPr>
+        <p:style>
+          <a:lnRef idx="2">
+            <a:schemeClr val="accent1"/>
+          </a:lnRef>
+          <a:fillRef idx="0">
+            <a:schemeClr val="accent1"/>
+          </a:fillRef>
+          <a:effectRef idx="1">
+            <a:schemeClr val="accent1"/>
+          </a:effectRef>
+          <a:fontRef idx="minor">
+            <a:schemeClr val="tx1"/>
+          </a:fontRef>
+        </p:style>
+      </p:cxnSp>
     </p:spTree>
     <p:extLst>
       <p:ext uri="{BB962C8B-B14F-4D97-AF65-F5344CB8AC3E}">
@@ -18429,6 +19438,576 @@
           </a:graphicData>
         </a:graphic>
       </p:graphicFrame>
+      <p:sp>
+        <p:nvSpPr>
+          <p:cNvPr id="973" name="Rounded Rectangle 972"/>
+          <p:cNvSpPr/>
+          <p:nvPr/>
+        </p:nvSpPr>
+        <p:spPr>
+          <a:xfrm>
+            <a:off x="500000" y="2500000"/>
+            <a:ext cx="1260000" cy="720000"/>
+          </a:xfrm>
+          <a:prstGeom prst="roundRect">
+            <a:avLst>
+              <a:gd name="adj" fmla="val 10000"/>
+            </a:avLst>
+          </a:prstGeom>
+          <a:noFill/>
+          <a:ln w="12700">
+            <a:solidFill>
+              <a:srgbClr val="BFBFBF"/>
+            </a:solidFill>
+          </a:ln>
+          <a:effectLst/>
+        </p:spPr>
+        <p:style>
+          <a:lnRef idx="1">
+            <a:schemeClr val="accent1"/>
+          </a:lnRef>
+          <a:fillRef idx="3">
+            <a:schemeClr val="accent1"/>
+          </a:fillRef>
+          <a:effectRef idx="2">
+            <a:schemeClr val="accent1"/>
+          </a:effectRef>
+          <a:fontRef idx="minor">
+            <a:schemeClr val="lt1"/>
+          </a:fontRef>
+        </p:style>
+        <p:txBody>
+          <a:bodyPr rtlCol="0" anchor="ctr" wrap="square" lIns="45720" rIns="45720" tIns="36576" bIns="36576"/>
+          <a:lstStyle/>
+          <a:p>
+            <a:pPr algn="ctr"/>
+            <a:r>
+              <a:rPr sz="900" b="1" i="0">
+                <a:solidFill>
+                  <a:srgbClr val="404040"/>
+                </a:solidFill>
+                <a:latin typeface="Segoe UI"/>
+              </a:rPr>
+              <a:t>Confirm dispute amount &amp; customer account</a:t>
+            </a:r>
+          </a:p>
+        </p:txBody>
+      </p:sp>
+      <p:sp>
+        <p:nvSpPr>
+          <p:cNvPr id="974" name="Rounded Rectangle 973"/>
+          <p:cNvSpPr/>
+          <p:nvPr/>
+        </p:nvSpPr>
+        <p:spPr>
+          <a:xfrm>
+            <a:off x="2400000" y="2500000"/>
+            <a:ext cx="1260000" cy="720000"/>
+          </a:xfrm>
+          <a:prstGeom prst="roundRect">
+            <a:avLst>
+              <a:gd name="adj" fmla="val 10000"/>
+            </a:avLst>
+          </a:prstGeom>
+          <a:noFill/>
+          <a:ln w="12700">
+            <a:solidFill>
+              <a:srgbClr val="BFBFBF"/>
+            </a:solidFill>
+          </a:ln>
+          <a:effectLst/>
+        </p:spPr>
+        <p:style>
+          <a:lnRef idx="1">
+            <a:schemeClr val="accent1"/>
+          </a:lnRef>
+          <a:fillRef idx="3">
+            <a:schemeClr val="accent1"/>
+          </a:fillRef>
+          <a:effectRef idx="2">
+            <a:schemeClr val="accent1"/>
+          </a:effectRef>
+          <a:fontRef idx="minor">
+            <a:schemeClr val="lt1"/>
+          </a:fontRef>
+        </p:style>
+        <p:txBody>
+          <a:bodyPr rtlCol="0" anchor="ctr" wrap="square" lIns="45720" rIns="45720" tIns="36576" bIns="36576"/>
+          <a:lstStyle/>
+          <a:p>
+            <a:pPr algn="ctr"/>
+            <a:r>
+              <a:rPr sz="900" b="1" i="0">
+                <a:solidFill>
+                  <a:srgbClr val="404040"/>
+                </a:solidFill>
+                <a:latin typeface="Segoe UI"/>
+              </a:rPr>
+              <a:t>Document rationale &amp; approval</a:t>
+            </a:r>
+          </a:p>
+        </p:txBody>
+      </p:sp>
+      <p:sp>
+        <p:nvSpPr>
+          <p:cNvPr id="975" name="Rounded Rectangle 974"/>
+          <p:cNvSpPr/>
+          <p:nvPr/>
+        </p:nvSpPr>
+        <p:spPr>
+          <a:xfrm>
+            <a:off x="4300000" y="2500000"/>
+            <a:ext cx="1260000" cy="720000"/>
+          </a:xfrm>
+          <a:prstGeom prst="roundRect">
+            <a:avLst>
+              <a:gd name="adj" fmla="val 10000"/>
+            </a:avLst>
+          </a:prstGeom>
+          <a:noFill/>
+          <a:ln w="12700">
+            <a:solidFill>
+              <a:srgbClr val="BFBFBF"/>
+            </a:solidFill>
+          </a:ln>
+          <a:effectLst/>
+        </p:spPr>
+        <p:style>
+          <a:lnRef idx="1">
+            <a:schemeClr val="accent1"/>
+          </a:lnRef>
+          <a:fillRef idx="3">
+            <a:schemeClr val="accent1"/>
+          </a:fillRef>
+          <a:effectRef idx="2">
+            <a:schemeClr val="accent1"/>
+          </a:effectRef>
+          <a:fontRef idx="minor">
+            <a:schemeClr val="lt1"/>
+          </a:fontRef>
+        </p:style>
+        <p:txBody>
+          <a:bodyPr rtlCol="0" anchor="ctr" wrap="square" lIns="45720" rIns="45720" tIns="36576" bIns="36576"/>
+          <a:lstStyle/>
+          <a:p>
+            <a:pPr algn="ctr"/>
+            <a:r>
+              <a:rPr sz="900" b="1" i="0">
+                <a:solidFill>
+                  <a:srgbClr val="404040"/>
+                </a:solidFill>
+                <a:latin typeface="Segoe UI"/>
+              </a:rPr>
+              <a:t>Post provisional credit within Visa SLA</a:t>
+            </a:r>
+          </a:p>
+        </p:txBody>
+      </p:sp>
+      <p:sp>
+        <p:nvSpPr>
+          <p:cNvPr id="976" name="Rounded Rectangle 975"/>
+          <p:cNvSpPr/>
+          <p:nvPr/>
+        </p:nvSpPr>
+        <p:spPr>
+          <a:xfrm>
+            <a:off x="6200000" y="2500000"/>
+            <a:ext cx="1260000" cy="720000"/>
+          </a:xfrm>
+          <a:prstGeom prst="roundRect">
+            <a:avLst>
+              <a:gd name="adj" fmla="val 10000"/>
+            </a:avLst>
+          </a:prstGeom>
+          <a:solidFill>
+            <a:srgbClr val="EDDBFB">
+              <a:alpha val="56863"/>
+            </a:srgbClr>
+          </a:solidFill>
+          <a:ln w="12700">
+            <a:solidFill>
+              <a:srgbClr val="9B40EA"/>
+            </a:solidFill>
+          </a:ln>
+          <a:effectLst/>
+        </p:spPr>
+        <p:style>
+          <a:lnRef idx="1">
+            <a:schemeClr val="accent1"/>
+          </a:lnRef>
+          <a:fillRef idx="3">
+            <a:schemeClr val="accent1"/>
+          </a:fillRef>
+          <a:effectRef idx="2">
+            <a:schemeClr val="accent1"/>
+          </a:effectRef>
+          <a:fontRef idx="minor">
+            <a:schemeClr val="lt1"/>
+          </a:fontRef>
+        </p:style>
+        <p:txBody>
+          <a:bodyPr rtlCol="0" anchor="ctr" wrap="square" lIns="45720" rIns="45720" tIns="36576" bIns="36576"/>
+          <a:lstStyle/>
+          <a:p>
+            <a:pPr algn="ctr"/>
+            <a:r>
+              <a:rPr sz="900" b="1" i="0">
+                <a:solidFill>
+                  <a:srgbClr val="404040"/>
+                </a:solidFill>
+                <a:latin typeface="Segoe UI"/>
+              </a:rPr>
+              <a:t>Notify customer of provisional credit issued</a:t>
+            </a:r>
+          </a:p>
+        </p:txBody>
+      </p:sp>
+      <p:sp>
+        <p:nvSpPr>
+          <p:cNvPr id="977" name="Rounded Rectangle 976"/>
+          <p:cNvSpPr/>
+          <p:nvPr/>
+        </p:nvSpPr>
+        <p:spPr>
+          <a:xfrm>
+            <a:off x="8100000" y="2500000"/>
+            <a:ext cx="1260000" cy="720000"/>
+          </a:xfrm>
+          <a:prstGeom prst="roundRect">
+            <a:avLst>
+              <a:gd name="adj" fmla="val 10000"/>
+            </a:avLst>
+          </a:prstGeom>
+          <a:noFill/>
+          <a:ln w="12700">
+            <a:solidFill>
+              <a:srgbClr val="BFBFBF"/>
+            </a:solidFill>
+          </a:ln>
+          <a:effectLst/>
+        </p:spPr>
+        <p:style>
+          <a:lnRef idx="1">
+            <a:schemeClr val="accent1"/>
+          </a:lnRef>
+          <a:fillRef idx="3">
+            <a:schemeClr val="accent1"/>
+          </a:fillRef>
+          <a:effectRef idx="2">
+            <a:schemeClr val="accent1"/>
+          </a:effectRef>
+          <a:fontRef idx="minor">
+            <a:schemeClr val="lt1"/>
+          </a:fontRef>
+        </p:style>
+        <p:txBody>
+          <a:bodyPr rtlCol="0" anchor="ctr" wrap="square" lIns="45720" rIns="45720" tIns="36576" bIns="36576"/>
+          <a:lstStyle/>
+          <a:p>
+            <a:pPr algn="ctr"/>
+            <a:r>
+              <a:rPr sz="900" b="1" i="0">
+                <a:solidFill>
+                  <a:srgbClr val="404040"/>
+                </a:solidFill>
+                <a:latin typeface="Segoe UI"/>
+              </a:rPr>
+              <a:t>Track provisional credit aging &amp; reversal</a:t>
+            </a:r>
+          </a:p>
+        </p:txBody>
+      </p:sp>
+      <p:grpSp>
+        <p:nvGrpSpPr>
+          <p:cNvPr id="9001" name="Handoff"/>
+          <p:cNvGrpSpPr/>
+          <p:nvPr/>
+        </p:nvGrpSpPr>
+        <p:grpSpPr>
+          <a:xfrm>
+            <a:off x="9660000" y="2734000"/>
+            <a:ext cx="252000" cy="252000"/>
+            <a:chOff x="9660000" y="2734000"/>
+            <a:chExt cx="252000" cy="252000"/>
+          </a:xfrm>
+        </p:grpSpPr>
+        <p:sp>
+          <p:nvSpPr>
+            <p:cNvPr id="9002" name="hoffc"/>
+            <p:cNvSpPr/>
+            <p:nvPr/>
+          </p:nvSpPr>
+          <p:spPr>
+            <a:xfrm>
+              <a:off x="9660000" y="2734000"/>
+              <a:ext cx="252000" cy="252000"/>
+            </a:xfrm>
+            <a:prstGeom prst="ellipse">
+              <a:avLst/>
+            </a:prstGeom>
+            <a:solidFill>
+              <a:srgbClr val="9DD4CF"/>
+            </a:solidFill>
+            <a:ln>
+              <a:noFill/>
+            </a:ln>
+          </p:spPr>
+          <p:txBody>
+            <a:bodyPr/>
+            <a:lstStyle/>
+            <a:p>
+              <a:endParaRPr lang="en-US"/>
+            </a:p>
+          </p:txBody>
+        </p:sp>
+        <p:sp>
+          <p:nvSpPr>
+            <p:cNvPr id="9003" name="hoffa"/>
+            <p:cNvSpPr/>
+            <p:nvPr/>
+          </p:nvSpPr>
+          <p:spPr>
+            <a:xfrm>
+              <a:off x="9710316" y="2797821"/>
+              <a:ext cx="161665" cy="124358"/>
+            </a:xfrm>
+            <a:prstGeom prst="rightArrow">
+              <a:avLst>
+                <a:gd name="adj1" fmla="val 50000"/>
+                <a:gd name="adj2" fmla="val 50000"/>
+              </a:avLst>
+            </a:prstGeom>
+            <a:solidFill>
+              <a:srgbClr val="FFFFFF"/>
+            </a:solidFill>
+            <a:ln>
+              <a:noFill/>
+            </a:ln>
+          </p:spPr>
+          <p:txBody>
+            <a:bodyPr/>
+            <a:lstStyle/>
+            <a:p>
+              <a:endParaRPr lang="en-US"/>
+            </a:p>
+          </p:txBody>
+        </p:sp>
+      </p:grpSp>
+      <p:cxnSp>
+        <p:nvCxnSpPr>
+          <p:cNvPr id="9004" name="Connector 9003"/>
+          <p:cNvCxnSpPr/>
+          <p:nvPr/>
+        </p:nvCxnSpPr>
+        <p:spPr>
+          <a:xfrm>
+            <a:off x="1760000" y="2860000"/>
+            <a:ext cx="640000" cy="0"/>
+          </a:xfrm>
+          <a:prstGeom prst="line">
+            <a:avLst/>
+          </a:prstGeom>
+          <a:ln w="19050">
+            <a:solidFill>
+              <a:srgbClr val="9B9B9B"/>
+            </a:solidFill>
+            <a:tailEnd type="triangle" w="med" len="med"/>
+          </a:ln>
+        </p:spPr>
+        <p:style>
+          <a:lnRef idx="2">
+            <a:schemeClr val="accent1"/>
+          </a:lnRef>
+          <a:fillRef idx="0">
+            <a:schemeClr val="accent1"/>
+          </a:fillRef>
+          <a:effectRef idx="1">
+            <a:schemeClr val="accent1"/>
+          </a:effectRef>
+          <a:fontRef idx="minor">
+            <a:schemeClr val="tx1"/>
+          </a:fontRef>
+        </p:style>
+      </p:cxnSp>
+      <p:cxnSp>
+        <p:nvCxnSpPr>
+          <p:cNvPr id="9005" name="Connector 9004"/>
+          <p:cNvCxnSpPr/>
+          <p:nvPr/>
+        </p:nvCxnSpPr>
+        <p:spPr>
+          <a:xfrm>
+            <a:off x="3660000" y="2860000"/>
+            <a:ext cx="640000" cy="0"/>
+          </a:xfrm>
+          <a:prstGeom prst="line">
+            <a:avLst/>
+          </a:prstGeom>
+          <a:ln w="19050">
+            <a:solidFill>
+              <a:srgbClr val="9B9B9B"/>
+            </a:solidFill>
+            <a:tailEnd type="triangle" w="med" len="med"/>
+          </a:ln>
+        </p:spPr>
+        <p:style>
+          <a:lnRef idx="2">
+            <a:schemeClr val="accent1"/>
+          </a:lnRef>
+          <a:fillRef idx="0">
+            <a:schemeClr val="accent1"/>
+          </a:fillRef>
+          <a:effectRef idx="1">
+            <a:schemeClr val="accent1"/>
+          </a:effectRef>
+          <a:fontRef idx="minor">
+            <a:schemeClr val="tx1"/>
+          </a:fontRef>
+        </p:style>
+      </p:cxnSp>
+      <p:cxnSp>
+        <p:nvCxnSpPr>
+          <p:cNvPr id="9006" name="Connector 9005"/>
+          <p:cNvCxnSpPr/>
+          <p:nvPr/>
+        </p:nvCxnSpPr>
+        <p:spPr>
+          <a:xfrm>
+            <a:off x="5560000" y="2860000"/>
+            <a:ext cx="640000" cy="0"/>
+          </a:xfrm>
+          <a:prstGeom prst="line">
+            <a:avLst/>
+          </a:prstGeom>
+          <a:ln w="19050">
+            <a:solidFill>
+              <a:srgbClr val="9B9B9B"/>
+            </a:solidFill>
+            <a:tailEnd type="triangle" w="med" len="med"/>
+          </a:ln>
+        </p:spPr>
+        <p:style>
+          <a:lnRef idx="2">
+            <a:schemeClr val="accent1"/>
+          </a:lnRef>
+          <a:fillRef idx="0">
+            <a:schemeClr val="accent1"/>
+          </a:fillRef>
+          <a:effectRef idx="1">
+            <a:schemeClr val="accent1"/>
+          </a:effectRef>
+          <a:fontRef idx="minor">
+            <a:schemeClr val="tx1"/>
+          </a:fontRef>
+        </p:style>
+      </p:cxnSp>
+      <p:cxnSp>
+        <p:nvCxnSpPr>
+          <p:cNvPr id="9007" name="Connector 9006"/>
+          <p:cNvCxnSpPr/>
+          <p:nvPr/>
+        </p:nvCxnSpPr>
+        <p:spPr>
+          <a:xfrm>
+            <a:off x="7460000" y="2860000"/>
+            <a:ext cx="640000" cy="0"/>
+          </a:xfrm>
+          <a:prstGeom prst="line">
+            <a:avLst/>
+          </a:prstGeom>
+          <a:ln w="19050">
+            <a:solidFill>
+              <a:srgbClr val="9B9B9B"/>
+            </a:solidFill>
+            <a:tailEnd type="triangle" w="med" len="med"/>
+          </a:ln>
+        </p:spPr>
+        <p:style>
+          <a:lnRef idx="2">
+            <a:schemeClr val="accent1"/>
+          </a:lnRef>
+          <a:fillRef idx="0">
+            <a:schemeClr val="accent1"/>
+          </a:fillRef>
+          <a:effectRef idx="1">
+            <a:schemeClr val="accent1"/>
+          </a:effectRef>
+          <a:fontRef idx="minor">
+            <a:schemeClr val="tx1"/>
+          </a:fontRef>
+        </p:style>
+      </p:cxnSp>
+      <p:cxnSp>
+        <p:nvCxnSpPr>
+          <p:cNvPr id="9008" name="Connector 9007"/>
+          <p:cNvCxnSpPr/>
+          <p:nvPr/>
+        </p:nvCxnSpPr>
+        <p:spPr>
+          <a:xfrm>
+            <a:off x="9360000" y="2860000"/>
+            <a:ext cx="300000" cy="0"/>
+          </a:xfrm>
+          <a:prstGeom prst="line">
+            <a:avLst/>
+          </a:prstGeom>
+          <a:ln w="19050">
+            <a:solidFill>
+              <a:srgbClr val="9B9B9B"/>
+            </a:solidFill>
+            <a:tailEnd type="triangle" w="med" len="med"/>
+          </a:ln>
+        </p:spPr>
+        <p:style>
+          <a:lnRef idx="2">
+            <a:schemeClr val="accent1"/>
+          </a:lnRef>
+          <a:fillRef idx="0">
+            <a:schemeClr val="accent1"/>
+          </a:fillRef>
+          <a:effectRef idx="1">
+            <a:schemeClr val="accent1"/>
+          </a:effectRef>
+          <a:fontRef idx="minor">
+            <a:schemeClr val="tx1"/>
+          </a:fontRef>
+        </p:style>
+      </p:cxnSp>
+      <p:sp>
+        <p:nvSpPr>
+          <p:cNvPr id="9009" name="TextBox 9008"/>
+          <p:cNvSpPr txBox="1"/>
+          <p:nvPr/>
+        </p:nvSpPr>
+        <p:spPr>
+          <a:xfrm>
+            <a:off x="4280000" y="3260000"/>
+            <a:ext cx="1300000" cy="430000"/>
+          </a:xfrm>
+          <a:prstGeom prst="rect">
+            <a:avLst/>
+          </a:prstGeom>
+          <a:noFill/>
+        </p:spPr>
+        <p:txBody>
+          <a:bodyPr wrap="square" lIns="45720" rIns="45720" tIns="36576" bIns="36576" anchor="ctr">
+            <a:spAutoFit/>
+          </a:bodyPr>
+          <a:lstStyle/>
+          <a:p>
+            <a:pPr algn="ctr"/>
+            <a:r>
+              <a:rPr sz="700" b="0" i="1">
+                <a:solidFill>
+                  <a:srgbClr val="404040"/>
+                </a:solidFill>
+                <a:latin typeface="Segoe UI"/>
+              </a:rPr>
+              <a:t>Per Visa dispute\nresolution SLA and\nBeem's cardholder agreement</a:t>
+            </a:r>
+          </a:p>
+        </p:txBody>
+      </p:sp>
     </p:spTree>
     <p:extLst>
       <p:ext uri="{BB962C8B-B14F-4D97-AF65-F5344CB8AC3E}">
@@ -19607,6 +21186,1106 @@
           </a:graphicData>
         </a:graphic>
       </p:graphicFrame>
+      <p:sp>
+        <p:nvSpPr>
+          <p:cNvPr id="973" name="Rounded Rectangle 972"/>
+          <p:cNvSpPr/>
+          <p:nvPr/>
+        </p:nvSpPr>
+        <p:spPr>
+          <a:xfrm>
+            <a:off x="300000" y="2500000"/>
+            <a:ext cx="1260000" cy="720000"/>
+          </a:xfrm>
+          <a:prstGeom prst="roundRect">
+            <a:avLst>
+              <a:gd name="adj" fmla="val 10000"/>
+            </a:avLst>
+          </a:prstGeom>
+          <a:noFill/>
+          <a:ln w="12700">
+            <a:solidFill>
+              <a:srgbClr val="BFBFBF"/>
+            </a:solidFill>
+          </a:ln>
+          <a:effectLst/>
+        </p:spPr>
+        <p:style>
+          <a:lnRef idx="1">
+            <a:schemeClr val="accent1"/>
+          </a:lnRef>
+          <a:fillRef idx="3">
+            <a:schemeClr val="accent1"/>
+          </a:fillRef>
+          <a:effectRef idx="2">
+            <a:schemeClr val="accent1"/>
+          </a:effectRef>
+          <a:fontRef idx="minor">
+            <a:schemeClr val="lt1"/>
+          </a:fontRef>
+        </p:style>
+        <p:txBody>
+          <a:bodyPr rtlCol="0" anchor="ctr" wrap="square" lIns="45720" rIns="45720" tIns="36576" bIns="36576"/>
+          <a:lstStyle/>
+          <a:p>
+            <a:pPr algn="ctr"/>
+            <a:r>
+              <a:rPr sz="900" b="1" i="0">
+                <a:solidFill>
+                  <a:srgbClr val="404040"/>
+                </a:solidFill>
+                <a:latin typeface="Segoe UI"/>
+              </a:rPr>
+              <a:t>Submit dispute to Central 1 (file the dispute)</a:t>
+            </a:r>
+          </a:p>
+        </p:txBody>
+      </p:sp>
+      <p:sp>
+        <p:nvSpPr>
+          <p:cNvPr id="974" name="TextBox 973"/>
+          <p:cNvSpPr txBox="1"/>
+          <p:nvPr/>
+        </p:nvSpPr>
+        <p:spPr>
+          <a:xfrm>
+            <a:off x="280000" y="3260000"/>
+            <a:ext cx="1300000" cy="430000"/>
+          </a:xfrm>
+          <a:prstGeom prst="rect">
+            <a:avLst/>
+          </a:prstGeom>
+          <a:noFill/>
+        </p:spPr>
+        <p:txBody>
+          <a:bodyPr wrap="square" lIns="45720" rIns="45720" tIns="36576" bIns="36576" anchor="ctr">
+            <a:spAutoFit/>
+          </a:bodyPr>
+          <a:lstStyle/>
+          <a:p>
+            <a:pPr algn="ctr"/>
+            <a:r>
+              <a:rPr sz="700" b="0" i="1">
+                <a:solidFill>
+                  <a:srgbClr val="404040"/>
+                </a:solidFill>
+                <a:latin typeface="Segoe UI"/>
+              </a:rPr>
+              <a:t>120 days from transaction date (75 days in specific conditions)*</a:t>
+            </a:r>
+          </a:p>
+        </p:txBody>
+      </p:sp>
+      <p:sp>
+        <p:nvSpPr>
+          <p:cNvPr id="975" name="Rounded Rectangle 974"/>
+          <p:cNvSpPr/>
+          <p:nvPr/>
+        </p:nvSpPr>
+        <p:spPr>
+          <a:xfrm>
+            <a:off x="1820000" y="2500000"/>
+            <a:ext cx="1260000" cy="720000"/>
+          </a:xfrm>
+          <a:prstGeom prst="roundRect">
+            <a:avLst>
+              <a:gd name="adj" fmla="val 10000"/>
+            </a:avLst>
+          </a:prstGeom>
+          <a:noFill/>
+          <a:ln w="12700">
+            <a:solidFill>
+              <a:srgbClr val="BFBFBF"/>
+            </a:solidFill>
+          </a:ln>
+          <a:effectLst/>
+        </p:spPr>
+        <p:style>
+          <a:lnRef idx="1">
+            <a:schemeClr val="accent1"/>
+          </a:lnRef>
+          <a:fillRef idx="3">
+            <a:schemeClr val="accent1"/>
+          </a:fillRef>
+          <a:effectRef idx="2">
+            <a:schemeClr val="accent1"/>
+          </a:effectRef>
+          <a:fontRef idx="minor">
+            <a:schemeClr val="lt1"/>
+          </a:fontRef>
+        </p:style>
+        <p:txBody>
+          <a:bodyPr rtlCol="0" anchor="ctr" wrap="square" lIns="45720" rIns="45720" tIns="36576" bIns="36576"/>
+          <a:lstStyle/>
+          <a:p>
+            <a:pPr algn="ctr"/>
+            <a:r>
+              <a:rPr sz="900" b="1" i="0">
+                <a:solidFill>
+                  <a:srgbClr val="404040"/>
+                </a:solidFill>
+                <a:latin typeface="Segoe UI"/>
+              </a:rPr>
+              <a:t>Monitor for Acquirer Dispute Response</a:t>
+            </a:r>
+          </a:p>
+        </p:txBody>
+      </p:sp>
+      <p:sp>
+        <p:nvSpPr>
+          <p:cNvPr id="976" name="Diamond 975"/>
+          <p:cNvSpPr/>
+          <p:nvPr/>
+        </p:nvSpPr>
+        <p:spPr>
+          <a:xfrm>
+            <a:off x="3530000" y="2425660"/>
+            <a:ext cx="1296000" cy="868680"/>
+          </a:xfrm>
+          <a:prstGeom prst="diamond">
+            <a:avLst/>
+          </a:prstGeom>
+          <a:solidFill>
+            <a:srgbClr val="FFFFFF"/>
+          </a:solidFill>
+          <a:ln w="12700">
+            <a:solidFill>
+              <a:srgbClr val="BFBFBF"/>
+            </a:solidFill>
+          </a:ln>
+          <a:effectLst/>
+        </p:spPr>
+        <p:style>
+          <a:lnRef idx="1">
+            <a:schemeClr val="accent1"/>
+          </a:lnRef>
+          <a:fillRef idx="3">
+            <a:schemeClr val="accent1"/>
+          </a:fillRef>
+          <a:effectRef idx="2">
+            <a:schemeClr val="accent1"/>
+          </a:effectRef>
+          <a:fontRef idx="minor">
+            <a:schemeClr val="lt1"/>
+          </a:fontRef>
+        </p:style>
+        <p:txBody>
+          <a:bodyPr rtlCol="0" anchor="ctr" wrap="square" lIns="0" rIns="0" tIns="36576" bIns="36576"/>
+          <a:lstStyle/>
+          <a:p>
+            <a:pPr algn="ctr"/>
+            <a:r>
+              <a:rPr sz="900" b="1" i="0">
+                <a:solidFill>
+                  <a:srgbClr val="404040"/>
+                </a:solidFill>
+                <a:latin typeface="Segoe UI"/>
+              </a:rPr>
+              <a:t>Acquirer accepts liability?</a:t>
+            </a:r>
+          </a:p>
+        </p:txBody>
+      </p:sp>
+      <p:sp>
+        <p:nvSpPr>
+          <p:cNvPr id="977" name="TextBox 976"/>
+          <p:cNvSpPr txBox="1"/>
+          <p:nvPr/>
+        </p:nvSpPr>
+        <p:spPr>
+          <a:xfrm>
+            <a:off x="3510000" y="3334340"/>
+            <a:ext cx="1300000" cy="300000"/>
+          </a:xfrm>
+          <a:prstGeom prst="rect">
+            <a:avLst/>
+          </a:prstGeom>
+          <a:noFill/>
+        </p:spPr>
+        <p:txBody>
+          <a:bodyPr wrap="square" lIns="45720" rIns="45720" tIns="36576" bIns="36576" anchor="ctr">
+            <a:spAutoFit/>
+          </a:bodyPr>
+          <a:lstStyle/>
+          <a:p>
+            <a:pPr algn="ctr"/>
+            <a:r>
+              <a:rPr sz="700" b="0" i="1">
+                <a:solidFill>
+                  <a:srgbClr val="404040"/>
+                </a:solidFill>
+                <a:latin typeface="Segoe UI"/>
+              </a:rPr>
+              <a:t>Acquirer response: 30 days</a:t>
+            </a:r>
+          </a:p>
+        </p:txBody>
+      </p:sp>
+      <p:sp>
+        <p:nvSpPr>
+          <p:cNvPr id="978" name="Rounded Rectangle 977"/>
+          <p:cNvSpPr/>
+          <p:nvPr/>
+        </p:nvSpPr>
+        <p:spPr>
+          <a:xfrm>
+            <a:off x="5276000" y="2500000"/>
+            <a:ext cx="1260000" cy="720000"/>
+          </a:xfrm>
+          <a:prstGeom prst="roundRect">
+            <a:avLst>
+              <a:gd name="adj" fmla="val 10000"/>
+            </a:avLst>
+          </a:prstGeom>
+          <a:noFill/>
+          <a:ln w="12700">
+            <a:solidFill>
+              <a:srgbClr val="BFBFBF"/>
+            </a:solidFill>
+          </a:ln>
+          <a:effectLst/>
+        </p:spPr>
+        <p:style>
+          <a:lnRef idx="1">
+            <a:schemeClr val="accent1"/>
+          </a:lnRef>
+          <a:fillRef idx="3">
+            <a:schemeClr val="accent1"/>
+          </a:fillRef>
+          <a:effectRef idx="2">
+            <a:schemeClr val="accent1"/>
+          </a:effectRef>
+          <a:fontRef idx="minor">
+            <a:schemeClr val="lt1"/>
+          </a:fontRef>
+        </p:style>
+        <p:txBody>
+          <a:bodyPr rtlCol="0" anchor="ctr" wrap="square" lIns="45720" rIns="45720" tIns="36576" bIns="36576"/>
+          <a:lstStyle/>
+          <a:p>
+            <a:pPr algn="ctr"/>
+            <a:r>
+              <a:rPr sz="900" b="1" i="0">
+                <a:solidFill>
+                  <a:srgbClr val="404040"/>
+                </a:solidFill>
+                <a:latin typeface="Segoe UI"/>
+              </a:rPr>
+              <a:t>Beem submits Pre-Arbitration (pushes back)</a:t>
+            </a:r>
+          </a:p>
+        </p:txBody>
+      </p:sp>
+      <p:sp>
+        <p:nvSpPr>
+          <p:cNvPr id="979" name="TextBox 978"/>
+          <p:cNvSpPr txBox="1"/>
+          <p:nvPr/>
+        </p:nvSpPr>
+        <p:spPr>
+          <a:xfrm>
+            <a:off x="5256000" y="3260000"/>
+            <a:ext cx="1300000" cy="250000"/>
+          </a:xfrm>
+          <a:prstGeom prst="rect">
+            <a:avLst/>
+          </a:prstGeom>
+          <a:noFill/>
+        </p:spPr>
+        <p:txBody>
+          <a:bodyPr wrap="square" lIns="45720" rIns="45720" tIns="36576" bIns="36576" anchor="ctr">
+            <a:spAutoFit/>
+          </a:bodyPr>
+          <a:lstStyle/>
+          <a:p>
+            <a:pPr algn="ctr"/>
+            <a:r>
+              <a:rPr sz="700" b="0" i="1">
+                <a:solidFill>
+                  <a:srgbClr val="404040"/>
+                </a:solidFill>
+                <a:latin typeface="Segoe UI"/>
+              </a:rPr>
+              <a:t>30 days</a:t>
+            </a:r>
+          </a:p>
+        </p:txBody>
+      </p:sp>
+      <p:sp>
+        <p:nvSpPr>
+          <p:cNvPr id="980" name="Rounded Rectangle 979"/>
+          <p:cNvSpPr/>
+          <p:nvPr/>
+        </p:nvSpPr>
+        <p:spPr>
+          <a:xfrm>
+            <a:off x="6796000" y="2500000"/>
+            <a:ext cx="1260000" cy="720000"/>
+          </a:xfrm>
+          <a:prstGeom prst="roundRect">
+            <a:avLst>
+              <a:gd name="adj" fmla="val 10000"/>
+            </a:avLst>
+          </a:prstGeom>
+          <a:noFill/>
+          <a:ln w="12700">
+            <a:solidFill>
+              <a:srgbClr val="BFBFBF"/>
+            </a:solidFill>
+          </a:ln>
+          <a:effectLst/>
+        </p:spPr>
+        <p:style>
+          <a:lnRef idx="1">
+            <a:schemeClr val="accent1"/>
+          </a:lnRef>
+          <a:fillRef idx="3">
+            <a:schemeClr val="accent1"/>
+          </a:fillRef>
+          <a:effectRef idx="2">
+            <a:schemeClr val="accent1"/>
+          </a:effectRef>
+          <a:fontRef idx="minor">
+            <a:schemeClr val="lt1"/>
+          </a:fontRef>
+        </p:style>
+        <p:txBody>
+          <a:bodyPr rtlCol="0" anchor="ctr" wrap="square" lIns="45720" rIns="45720" tIns="36576" bIns="36576"/>
+          <a:lstStyle/>
+          <a:p>
+            <a:pPr algn="ctr"/>
+            <a:r>
+              <a:rPr sz="900" b="1" i="0">
+                <a:solidFill>
+                  <a:srgbClr val="404040"/>
+                </a:solidFill>
+                <a:latin typeface="Segoe UI"/>
+              </a:rPr>
+              <a:t>Acquirer Pre-Arbitration response</a:t>
+            </a:r>
+          </a:p>
+        </p:txBody>
+      </p:sp>
+      <p:sp>
+        <p:nvSpPr>
+          <p:cNvPr id="981" name="TextBox 980"/>
+          <p:cNvSpPr txBox="1"/>
+          <p:nvPr/>
+        </p:nvSpPr>
+        <p:spPr>
+          <a:xfrm>
+            <a:off x="6776000" y="3260000"/>
+            <a:ext cx="1300000" cy="250000"/>
+          </a:xfrm>
+          <a:prstGeom prst="rect">
+            <a:avLst/>
+          </a:prstGeom>
+          <a:noFill/>
+        </p:spPr>
+        <p:txBody>
+          <a:bodyPr wrap="square" lIns="45720" rIns="45720" tIns="36576" bIns="36576" anchor="ctr">
+            <a:spAutoFit/>
+          </a:bodyPr>
+          <a:lstStyle/>
+          <a:p>
+            <a:pPr algn="ctr"/>
+            <a:r>
+              <a:rPr sz="700" b="0" i="1">
+                <a:solidFill>
+                  <a:srgbClr val="404040"/>
+                </a:solidFill>
+                <a:latin typeface="Segoe UI"/>
+              </a:rPr>
+              <a:t>30 days</a:t>
+            </a:r>
+          </a:p>
+        </p:txBody>
+      </p:sp>
+      <p:sp>
+        <p:nvSpPr>
+          <p:cNvPr id="982" name="Diamond 981"/>
+          <p:cNvSpPr/>
+          <p:nvPr/>
+        </p:nvSpPr>
+        <p:spPr>
+          <a:xfrm>
+            <a:off x="8506000" y="2425660"/>
+            <a:ext cx="1296000" cy="868680"/>
+          </a:xfrm>
+          <a:prstGeom prst="diamond">
+            <a:avLst/>
+          </a:prstGeom>
+          <a:solidFill>
+            <a:srgbClr val="FFFFFF"/>
+          </a:solidFill>
+          <a:ln w="12700">
+            <a:solidFill>
+              <a:srgbClr val="BFBFBF"/>
+            </a:solidFill>
+          </a:ln>
+          <a:effectLst/>
+        </p:spPr>
+        <p:style>
+          <a:lnRef idx="1">
+            <a:schemeClr val="accent1"/>
+          </a:lnRef>
+          <a:fillRef idx="3">
+            <a:schemeClr val="accent1"/>
+          </a:fillRef>
+          <a:effectRef idx="2">
+            <a:schemeClr val="accent1"/>
+          </a:effectRef>
+          <a:fontRef idx="minor">
+            <a:schemeClr val="lt1"/>
+          </a:fontRef>
+        </p:style>
+        <p:txBody>
+          <a:bodyPr rtlCol="0" anchor="ctr" wrap="square" lIns="0" rIns="0" tIns="36576" bIns="36576"/>
+          <a:lstStyle/>
+          <a:p>
+            <a:pPr algn="ctr"/>
+            <a:r>
+              <a:rPr sz="900" b="1" i="0">
+                <a:solidFill>
+                  <a:srgbClr val="404040"/>
+                </a:solidFill>
+                <a:latin typeface="Segoe UI"/>
+              </a:rPr>
+              <a:t>Resolved at pre-arb?</a:t>
+            </a:r>
+          </a:p>
+        </p:txBody>
+      </p:sp>
+      <p:sp>
+        <p:nvSpPr>
+          <p:cNvPr id="983" name="Rounded Rectangle 982"/>
+          <p:cNvSpPr/>
+          <p:nvPr/>
+        </p:nvSpPr>
+        <p:spPr>
+          <a:xfrm>
+            <a:off x="10252000" y="2500000"/>
+            <a:ext cx="1260000" cy="720000"/>
+          </a:xfrm>
+          <a:prstGeom prst="roundRect">
+            <a:avLst>
+              <a:gd name="adj" fmla="val 10000"/>
+            </a:avLst>
+          </a:prstGeom>
+          <a:noFill/>
+          <a:ln w="12700">
+            <a:solidFill>
+              <a:srgbClr val="BFBFBF"/>
+            </a:solidFill>
+          </a:ln>
+          <a:effectLst/>
+        </p:spPr>
+        <p:style>
+          <a:lnRef idx="1">
+            <a:schemeClr val="accent1"/>
+          </a:lnRef>
+          <a:fillRef idx="3">
+            <a:schemeClr val="accent1"/>
+          </a:fillRef>
+          <a:effectRef idx="2">
+            <a:schemeClr val="accent1"/>
+          </a:effectRef>
+          <a:fontRef idx="minor">
+            <a:schemeClr val="lt1"/>
+          </a:fontRef>
+        </p:style>
+        <p:txBody>
+          <a:bodyPr rtlCol="0" anchor="ctr" wrap="square" lIns="45720" rIns="45720" tIns="36576" bIns="36576"/>
+          <a:lstStyle/>
+          <a:p>
+            <a:pPr algn="ctr"/>
+            <a:r>
+              <a:rPr sz="900" b="1" i="0">
+                <a:solidFill>
+                  <a:srgbClr val="404040"/>
+                </a:solidFill>
+                <a:latin typeface="Segoe UI"/>
+              </a:rPr>
+              <a:t>Escalate to Arbitration</a:t>
+            </a:r>
+          </a:p>
+        </p:txBody>
+      </p:sp>
+      <p:grpSp>
+        <p:nvGrpSpPr>
+          <p:cNvPr id="9001" name="Handoff"/>
+          <p:cNvGrpSpPr/>
+          <p:nvPr/>
+        </p:nvGrpSpPr>
+        <p:grpSpPr>
+          <a:xfrm>
+            <a:off x="11812000" y="1900000"/>
+            <a:ext cx="252000" cy="252000"/>
+            <a:chOff x="11812000" y="1900000"/>
+            <a:chExt cx="252000" cy="252000"/>
+          </a:xfrm>
+        </p:grpSpPr>
+        <p:sp>
+          <p:nvSpPr>
+            <p:cNvPr id="9002" name="hoffc"/>
+            <p:cNvSpPr/>
+            <p:nvPr/>
+          </p:nvSpPr>
+          <p:spPr>
+            <a:xfrm>
+              <a:off x="11812000" y="1900000"/>
+              <a:ext cx="252000" cy="252000"/>
+            </a:xfrm>
+            <a:prstGeom prst="ellipse">
+              <a:avLst/>
+            </a:prstGeom>
+            <a:solidFill>
+              <a:srgbClr val="9DD4CF"/>
+            </a:solidFill>
+            <a:ln>
+              <a:noFill/>
+            </a:ln>
+          </p:spPr>
+          <p:txBody>
+            <a:bodyPr/>
+            <a:lstStyle/>
+            <a:p>
+              <a:endParaRPr lang="en-US"/>
+            </a:p>
+          </p:txBody>
+        </p:sp>
+        <p:sp>
+          <p:nvSpPr>
+            <p:cNvPr id="9003" name="hoffa"/>
+            <p:cNvSpPr/>
+            <p:nvPr/>
+          </p:nvSpPr>
+          <p:spPr>
+            <a:xfrm>
+              <a:off x="11862316" y="1963821"/>
+              <a:ext cx="161665" cy="124358"/>
+            </a:xfrm>
+            <a:prstGeom prst="rightArrow">
+              <a:avLst>
+                <a:gd name="adj1" fmla="val 50000"/>
+                <a:gd name="adj2" fmla="val 50000"/>
+              </a:avLst>
+            </a:prstGeom>
+            <a:solidFill>
+              <a:srgbClr val="FFFFFF"/>
+            </a:solidFill>
+            <a:ln>
+              <a:noFill/>
+            </a:ln>
+          </p:spPr>
+          <p:txBody>
+            <a:bodyPr/>
+            <a:lstStyle/>
+            <a:p>
+              <a:endParaRPr lang="en-US"/>
+            </a:p>
+          </p:txBody>
+        </p:sp>
+      </p:grpSp>
+      <p:cxnSp>
+        <p:nvCxnSpPr>
+          <p:cNvPr id="9004" name="Connector 9003"/>
+          <p:cNvCxnSpPr/>
+          <p:nvPr/>
+        </p:nvCxnSpPr>
+        <p:spPr>
+          <a:xfrm>
+            <a:off x="1560000" y="2860000"/>
+            <a:ext cx="260000" cy="0"/>
+          </a:xfrm>
+          <a:prstGeom prst="line">
+            <a:avLst/>
+          </a:prstGeom>
+          <a:ln w="19050">
+            <a:solidFill>
+              <a:srgbClr val="9B9B9B"/>
+            </a:solidFill>
+            <a:tailEnd type="triangle" w="med" len="med"/>
+          </a:ln>
+        </p:spPr>
+        <p:style>
+          <a:lnRef idx="2">
+            <a:schemeClr val="accent1"/>
+          </a:lnRef>
+          <a:fillRef idx="0">
+            <a:schemeClr val="accent1"/>
+          </a:fillRef>
+          <a:effectRef idx="1">
+            <a:schemeClr val="accent1"/>
+          </a:effectRef>
+          <a:fontRef idx="minor">
+            <a:schemeClr val="tx1"/>
+          </a:fontRef>
+        </p:style>
+      </p:cxnSp>
+      <p:cxnSp>
+        <p:nvCxnSpPr>
+          <p:cNvPr id="9005" name="Connector 9004"/>
+          <p:cNvCxnSpPr/>
+          <p:nvPr/>
+        </p:nvCxnSpPr>
+        <p:spPr>
+          <a:xfrm>
+            <a:off x="3080000" y="2860000"/>
+            <a:ext cx="450000" cy="0"/>
+          </a:xfrm>
+          <a:prstGeom prst="line">
+            <a:avLst/>
+          </a:prstGeom>
+          <a:ln w="19050">
+            <a:solidFill>
+              <a:srgbClr val="9B9B9B"/>
+            </a:solidFill>
+            <a:tailEnd type="triangle" w="med" len="med"/>
+          </a:ln>
+        </p:spPr>
+        <p:style>
+          <a:lnRef idx="2">
+            <a:schemeClr val="accent1"/>
+          </a:lnRef>
+          <a:fillRef idx="0">
+            <a:schemeClr val="accent1"/>
+          </a:fillRef>
+          <a:effectRef idx="1">
+            <a:schemeClr val="accent1"/>
+          </a:effectRef>
+          <a:fontRef idx="minor">
+            <a:schemeClr val="tx1"/>
+          </a:fontRef>
+        </p:style>
+      </p:cxnSp>
+      <p:cxnSp>
+        <p:nvCxnSpPr>
+          <p:cNvPr id="9006" name="Connector 9005"/>
+          <p:cNvCxnSpPr/>
+          <p:nvPr/>
+        </p:nvCxnSpPr>
+        <p:spPr>
+          <a:xfrm>
+            <a:off x="4826000" y="2860000"/>
+            <a:ext cx="450000" cy="0"/>
+          </a:xfrm>
+          <a:prstGeom prst="line">
+            <a:avLst/>
+          </a:prstGeom>
+          <a:ln w="19050">
+            <a:solidFill>
+              <a:srgbClr val="9B9B9B"/>
+            </a:solidFill>
+            <a:tailEnd type="triangle" w="med" len="med"/>
+          </a:ln>
+        </p:spPr>
+        <p:style>
+          <a:lnRef idx="2">
+            <a:schemeClr val="accent1"/>
+          </a:lnRef>
+          <a:fillRef idx="0">
+            <a:schemeClr val="accent1"/>
+          </a:fillRef>
+          <a:effectRef idx="1">
+            <a:schemeClr val="accent1"/>
+          </a:effectRef>
+          <a:fontRef idx="minor">
+            <a:schemeClr val="tx1"/>
+          </a:fontRef>
+        </p:style>
+      </p:cxnSp>
+      <p:sp>
+        <p:nvSpPr>
+          <p:cNvPr id="9007" name="TextBox 9006"/>
+          <p:cNvSpPr txBox="1"/>
+          <p:nvPr/>
+        </p:nvSpPr>
+        <p:spPr>
+          <a:xfrm>
+            <a:off x="4866000" y="2580000"/>
+            <a:ext cx="620000" cy="260000"/>
+          </a:xfrm>
+          <a:prstGeom prst="rect">
+            <a:avLst/>
+          </a:prstGeom>
+          <a:noFill/>
+        </p:spPr>
+        <p:txBody>
+          <a:bodyPr wrap="square" lIns="45720" rIns="45720" tIns="36576" bIns="36576" anchor="ctr">
+            <a:spAutoFit/>
+          </a:bodyPr>
+          <a:lstStyle/>
+          <a:p>
+            <a:pPr algn="ctr"/>
+            <a:r>
+              <a:rPr sz="900" b="1" i="0">
+                <a:solidFill>
+                  <a:srgbClr val="C00000"/>
+                </a:solidFill>
+                <a:latin typeface="Segoe UI"/>
+              </a:rPr>
+              <a:t>No</a:t>
+            </a:r>
+          </a:p>
+        </p:txBody>
+      </p:sp>
+      <p:cxnSp>
+        <p:nvCxnSpPr>
+          <p:cNvPr id="9008" name="Connector 9007"/>
+          <p:cNvCxnSpPr/>
+          <p:nvPr/>
+        </p:nvCxnSpPr>
+        <p:spPr>
+          <a:xfrm flipV="1">
+            <a:off x="4178000" y="2152000"/>
+            <a:ext cx="7760000" cy="273660"/>
+          </a:xfrm>
+          <a:prstGeom prst="bentConnector3">
+            <a:avLst/>
+          </a:prstGeom>
+          <a:ln w="19050">
+            <a:solidFill>
+              <a:srgbClr val="9B9B9B"/>
+            </a:solidFill>
+            <a:tailEnd type="triangle" w="med" len="med"/>
+          </a:ln>
+        </p:spPr>
+        <p:style>
+          <a:lnRef idx="2">
+            <a:schemeClr val="accent1"/>
+          </a:lnRef>
+          <a:fillRef idx="0">
+            <a:schemeClr val="accent1"/>
+          </a:fillRef>
+          <a:effectRef idx="1">
+            <a:schemeClr val="accent1"/>
+          </a:effectRef>
+          <a:fontRef idx="minor">
+            <a:schemeClr val="tx1"/>
+          </a:fontRef>
+        </p:style>
+      </p:cxnSp>
+      <p:sp>
+        <p:nvSpPr>
+          <p:cNvPr id="9009" name="TextBox 9008"/>
+          <p:cNvSpPr txBox="1"/>
+          <p:nvPr/>
+        </p:nvSpPr>
+        <p:spPr>
+          <a:xfrm>
+            <a:off x="3858000" y="2145660"/>
+            <a:ext cx="620000" cy="260000"/>
+          </a:xfrm>
+          <a:prstGeom prst="rect">
+            <a:avLst/>
+          </a:prstGeom>
+          <a:noFill/>
+        </p:spPr>
+        <p:txBody>
+          <a:bodyPr wrap="square" lIns="45720" rIns="45720" tIns="36576" bIns="36576" anchor="ctr">
+            <a:spAutoFit/>
+          </a:bodyPr>
+          <a:lstStyle/>
+          <a:p>
+            <a:pPr algn="ctr"/>
+            <a:r>
+              <a:rPr sz="900" b="1" i="0">
+                <a:solidFill>
+                  <a:srgbClr val="009A44"/>
+                </a:solidFill>
+                <a:latin typeface="Segoe UI"/>
+              </a:rPr>
+              <a:t>Yes</a:t>
+            </a:r>
+          </a:p>
+        </p:txBody>
+      </p:sp>
+      <p:cxnSp>
+        <p:nvCxnSpPr>
+          <p:cNvPr id="9010" name="Connector 9009"/>
+          <p:cNvCxnSpPr/>
+          <p:nvPr/>
+        </p:nvCxnSpPr>
+        <p:spPr>
+          <a:xfrm>
+            <a:off x="6536000" y="2860000"/>
+            <a:ext cx="260000" cy="0"/>
+          </a:xfrm>
+          <a:prstGeom prst="line">
+            <a:avLst/>
+          </a:prstGeom>
+          <a:ln w="19050">
+            <a:solidFill>
+              <a:srgbClr val="9B9B9B"/>
+            </a:solidFill>
+            <a:tailEnd type="triangle" w="med" len="med"/>
+          </a:ln>
+        </p:spPr>
+        <p:style>
+          <a:lnRef idx="2">
+            <a:schemeClr val="accent1"/>
+          </a:lnRef>
+          <a:fillRef idx="0">
+            <a:schemeClr val="accent1"/>
+          </a:fillRef>
+          <a:effectRef idx="1">
+            <a:schemeClr val="accent1"/>
+          </a:effectRef>
+          <a:fontRef idx="minor">
+            <a:schemeClr val="tx1"/>
+          </a:fontRef>
+        </p:style>
+      </p:cxnSp>
+      <p:cxnSp>
+        <p:nvCxnSpPr>
+          <p:cNvPr id="9011" name="Connector 9010"/>
+          <p:cNvCxnSpPr/>
+          <p:nvPr/>
+        </p:nvCxnSpPr>
+        <p:spPr>
+          <a:xfrm>
+            <a:off x="8056000" y="2860000"/>
+            <a:ext cx="450000" cy="0"/>
+          </a:xfrm>
+          <a:prstGeom prst="line">
+            <a:avLst/>
+          </a:prstGeom>
+          <a:ln w="19050">
+            <a:solidFill>
+              <a:srgbClr val="9B9B9B"/>
+            </a:solidFill>
+            <a:tailEnd type="triangle" w="med" len="med"/>
+          </a:ln>
+        </p:spPr>
+        <p:style>
+          <a:lnRef idx="2">
+            <a:schemeClr val="accent1"/>
+          </a:lnRef>
+          <a:fillRef idx="0">
+            <a:schemeClr val="accent1"/>
+          </a:fillRef>
+          <a:effectRef idx="1">
+            <a:schemeClr val="accent1"/>
+          </a:effectRef>
+          <a:fontRef idx="minor">
+            <a:schemeClr val="tx1"/>
+          </a:fontRef>
+        </p:style>
+      </p:cxnSp>
+      <p:cxnSp>
+        <p:nvCxnSpPr>
+          <p:cNvPr id="9012" name="Connector 9011"/>
+          <p:cNvCxnSpPr/>
+          <p:nvPr/>
+        </p:nvCxnSpPr>
+        <p:spPr>
+          <a:xfrm flipV="1">
+            <a:off x="9154000" y="2152000"/>
+            <a:ext cx="2784000" cy="273660"/>
+          </a:xfrm>
+          <a:prstGeom prst="bentConnector3">
+            <a:avLst/>
+          </a:prstGeom>
+          <a:ln w="19050">
+            <a:solidFill>
+              <a:srgbClr val="9B9B9B"/>
+            </a:solidFill>
+            <a:tailEnd type="triangle" w="med" len="med"/>
+          </a:ln>
+        </p:spPr>
+        <p:style>
+          <a:lnRef idx="2">
+            <a:schemeClr val="accent1"/>
+          </a:lnRef>
+          <a:fillRef idx="0">
+            <a:schemeClr val="accent1"/>
+          </a:fillRef>
+          <a:effectRef idx="1">
+            <a:schemeClr val="accent1"/>
+          </a:effectRef>
+          <a:fontRef idx="minor">
+            <a:schemeClr val="tx1"/>
+          </a:fontRef>
+        </p:style>
+      </p:cxnSp>
+      <p:sp>
+        <p:nvSpPr>
+          <p:cNvPr id="9013" name="TextBox 9012"/>
+          <p:cNvSpPr txBox="1"/>
+          <p:nvPr/>
+        </p:nvSpPr>
+        <p:spPr>
+          <a:xfrm>
+            <a:off x="8834000" y="2145660"/>
+            <a:ext cx="620000" cy="260000"/>
+          </a:xfrm>
+          <a:prstGeom prst="rect">
+            <a:avLst/>
+          </a:prstGeom>
+          <a:noFill/>
+        </p:spPr>
+        <p:txBody>
+          <a:bodyPr wrap="square" lIns="45720" rIns="45720" tIns="36576" bIns="36576" anchor="ctr">
+            <a:spAutoFit/>
+          </a:bodyPr>
+          <a:lstStyle/>
+          <a:p>
+            <a:pPr algn="ctr"/>
+            <a:r>
+              <a:rPr sz="900" b="1" i="0">
+                <a:solidFill>
+                  <a:srgbClr val="009A44"/>
+                </a:solidFill>
+                <a:latin typeface="Segoe UI"/>
+              </a:rPr>
+              <a:t>Yes</a:t>
+            </a:r>
+          </a:p>
+        </p:txBody>
+      </p:sp>
+      <p:cxnSp>
+        <p:nvCxnSpPr>
+          <p:cNvPr id="9014" name="Connector 9013"/>
+          <p:cNvCxnSpPr/>
+          <p:nvPr/>
+        </p:nvCxnSpPr>
+        <p:spPr>
+          <a:xfrm>
+            <a:off x="9802000" y="2860000"/>
+            <a:ext cx="450000" cy="0"/>
+          </a:xfrm>
+          <a:prstGeom prst="line">
+            <a:avLst/>
+          </a:prstGeom>
+          <a:ln w="19050">
+            <a:solidFill>
+              <a:srgbClr val="9B9B9B"/>
+            </a:solidFill>
+            <a:tailEnd type="triangle" w="med" len="med"/>
+          </a:ln>
+        </p:spPr>
+        <p:style>
+          <a:lnRef idx="2">
+            <a:schemeClr val="accent1"/>
+          </a:lnRef>
+          <a:fillRef idx="0">
+            <a:schemeClr val="accent1"/>
+          </a:fillRef>
+          <a:effectRef idx="1">
+            <a:schemeClr val="accent1"/>
+          </a:effectRef>
+          <a:fontRef idx="minor">
+            <a:schemeClr val="tx1"/>
+          </a:fontRef>
+        </p:style>
+      </p:cxnSp>
+      <p:sp>
+        <p:nvSpPr>
+          <p:cNvPr id="9015" name="TextBox 9014"/>
+          <p:cNvSpPr txBox="1"/>
+          <p:nvPr/>
+        </p:nvSpPr>
+        <p:spPr>
+          <a:xfrm>
+            <a:off x="9842000" y="2580000"/>
+            <a:ext cx="620000" cy="260000"/>
+          </a:xfrm>
+          <a:prstGeom prst="rect">
+            <a:avLst/>
+          </a:prstGeom>
+          <a:noFill/>
+        </p:spPr>
+        <p:txBody>
+          <a:bodyPr wrap="square" lIns="45720" rIns="45720" tIns="36576" bIns="36576" anchor="ctr">
+            <a:spAutoFit/>
+          </a:bodyPr>
+          <a:lstStyle/>
+          <a:p>
+            <a:pPr algn="ctr"/>
+            <a:r>
+              <a:rPr sz="900" b="1" i="0">
+                <a:solidFill>
+                  <a:srgbClr val="C00000"/>
+                </a:solidFill>
+                <a:latin typeface="Segoe UI"/>
+              </a:rPr>
+              <a:t>No</a:t>
+            </a:r>
+          </a:p>
+        </p:txBody>
+      </p:sp>
+      <p:cxnSp>
+        <p:nvCxnSpPr>
+          <p:cNvPr id="9016" name="Connector 9015"/>
+          <p:cNvCxnSpPr/>
+          <p:nvPr/>
+        </p:nvCxnSpPr>
+        <p:spPr>
+          <a:xfrm flipV="1">
+            <a:off x="10882000" y="2152000"/>
+            <a:ext cx="1056000" cy="348000"/>
+          </a:xfrm>
+          <a:prstGeom prst="bentConnector3">
+            <a:avLst/>
+          </a:prstGeom>
+          <a:ln w="19050">
+            <a:solidFill>
+              <a:srgbClr val="9B9B9B"/>
+            </a:solidFill>
+            <a:tailEnd type="triangle" w="med" len="med"/>
+          </a:ln>
+        </p:spPr>
+        <p:style>
+          <a:lnRef idx="2">
+            <a:schemeClr val="accent1"/>
+          </a:lnRef>
+          <a:fillRef idx="0">
+            <a:schemeClr val="accent1"/>
+          </a:fillRef>
+          <a:effectRef idx="1">
+            <a:schemeClr val="accent1"/>
+          </a:effectRef>
+          <a:fontRef idx="minor">
+            <a:schemeClr val="tx1"/>
+          </a:fontRef>
+        </p:style>
+      </p:cxnSp>
+      <p:sp>
+        <p:nvSpPr>
+          <p:cNvPr id="9017" name="TextBox 9016"/>
+          <p:cNvSpPr txBox="1"/>
+          <p:nvPr/>
+        </p:nvSpPr>
+        <p:spPr>
+          <a:xfrm>
+            <a:off x="5276000" y="4120000"/>
+            <a:ext cx="2600000" cy="300000"/>
+          </a:xfrm>
+          <a:prstGeom prst="rect">
+            <a:avLst/>
+          </a:prstGeom>
+          <a:noFill/>
+        </p:spPr>
+        <p:txBody>
+          <a:bodyPr wrap="square" lIns="45720" rIns="45720" tIns="36576" bIns="36576" anchor="ctr">
+            <a:spAutoFit/>
+          </a:bodyPr>
+          <a:lstStyle/>
+          <a:p>
+            <a:pPr algn="ctr"/>
+            <a:r>
+              <a:rPr sz="700" b="0" i="1">
+                <a:solidFill>
+                  <a:srgbClr val="404040"/>
+                </a:solidFill>
+                <a:latin typeface="Segoe UI"/>
+              </a:rPr>
+              <a:t>Complete case audit trail is maintained throughout Stage 4</a:t>
+            </a:r>
+          </a:p>
+        </p:txBody>
+      </p:sp>
     </p:spTree>
     <p:extLst>
       <p:ext uri="{BB962C8B-B14F-4D97-AF65-F5344CB8AC3E}">
@@ -20783,6 +23462,787 @@
           </a:graphicData>
         </a:graphic>
       </p:graphicFrame>
+      <p:sp>
+        <p:nvSpPr>
+          <p:cNvPr id="973" name="Rounded Rectangle 972"/>
+          <p:cNvSpPr/>
+          <p:nvPr/>
+        </p:nvSpPr>
+        <p:spPr>
+          <a:xfrm>
+            <a:off x="300000" y="2500000"/>
+            <a:ext cx="1260000" cy="720000"/>
+          </a:xfrm>
+          <a:prstGeom prst="roundRect">
+            <a:avLst>
+              <a:gd name="adj" fmla="val 10000"/>
+            </a:avLst>
+          </a:prstGeom>
+          <a:noFill/>
+          <a:ln w="12700">
+            <a:solidFill>
+              <a:srgbClr val="BFBFBF"/>
+            </a:solidFill>
+          </a:ln>
+          <a:effectLst/>
+        </p:spPr>
+        <p:style>
+          <a:lnRef idx="1">
+            <a:schemeClr val="accent1"/>
+          </a:lnRef>
+          <a:fillRef idx="3">
+            <a:schemeClr val="accent1"/>
+          </a:fillRef>
+          <a:effectRef idx="2">
+            <a:schemeClr val="accent1"/>
+          </a:effectRef>
+          <a:fontRef idx="minor">
+            <a:schemeClr val="lt1"/>
+          </a:fontRef>
+        </p:style>
+        <p:txBody>
+          <a:bodyPr rtlCol="0" anchor="ctr" wrap="square" lIns="45720" rIns="45720" tIns="36576" bIns="36576"/>
+          <a:lstStyle/>
+          <a:p>
+            <a:pPr algn="ctr"/>
+            <a:r>
+              <a:rPr sz="900" b="1" i="0">
+                <a:solidFill>
+                  <a:srgbClr val="404040"/>
+                </a:solidFill>
+                <a:latin typeface="Segoe UI"/>
+              </a:rPr>
+              <a:t>Visa Arbitration ruling (if escalated)</a:t>
+            </a:r>
+          </a:p>
+        </p:txBody>
+      </p:sp>
+      <p:sp>
+        <p:nvSpPr>
+          <p:cNvPr id="974" name="TextBox 973"/>
+          <p:cNvSpPr txBox="1"/>
+          <p:nvPr/>
+        </p:nvSpPr>
+        <p:spPr>
+          <a:xfrm>
+            <a:off x="280000" y="3260000"/>
+            <a:ext cx="1300000" cy="250000"/>
+          </a:xfrm>
+          <a:prstGeom prst="rect">
+            <a:avLst/>
+          </a:prstGeom>
+          <a:noFill/>
+        </p:spPr>
+        <p:txBody>
+          <a:bodyPr wrap="square" lIns="45720" rIns="45720" tIns="36576" bIns="36576" anchor="ctr">
+            <a:spAutoFit/>
+          </a:bodyPr>
+          <a:lstStyle/>
+          <a:p>
+            <a:pPr algn="ctr"/>
+            <a:r>
+              <a:rPr sz="700" b="0" i="1">
+                <a:solidFill>
+                  <a:srgbClr val="404040"/>
+                </a:solidFill>
+                <a:latin typeface="Segoe UI"/>
+              </a:rPr>
+              <a:t>10 days</a:t>
+            </a:r>
+          </a:p>
+        </p:txBody>
+      </p:sp>
+      <p:sp>
+        <p:nvSpPr>
+          <p:cNvPr id="975" name="Diamond 974"/>
+          <p:cNvSpPr/>
+          <p:nvPr/>
+        </p:nvSpPr>
+        <p:spPr>
+          <a:xfrm>
+            <a:off x="2010000" y="2425660"/>
+            <a:ext cx="1296000" cy="868680"/>
+          </a:xfrm>
+          <a:prstGeom prst="diamond">
+            <a:avLst/>
+          </a:prstGeom>
+          <a:solidFill>
+            <a:srgbClr val="FFFFFF"/>
+          </a:solidFill>
+          <a:ln w="12700">
+            <a:solidFill>
+              <a:srgbClr val="BFBFBF"/>
+            </a:solidFill>
+          </a:ln>
+          <a:effectLst/>
+        </p:spPr>
+        <p:style>
+          <a:lnRef idx="1">
+            <a:schemeClr val="accent1"/>
+          </a:lnRef>
+          <a:fillRef idx="3">
+            <a:schemeClr val="accent1"/>
+          </a:fillRef>
+          <a:effectRef idx="2">
+            <a:schemeClr val="accent1"/>
+          </a:effectRef>
+          <a:fontRef idx="minor">
+            <a:schemeClr val="lt1"/>
+          </a:fontRef>
+        </p:style>
+        <p:txBody>
+          <a:bodyPr rtlCol="0" anchor="ctr" wrap="square" lIns="0" rIns="0" tIns="36576" bIns="36576"/>
+          <a:lstStyle/>
+          <a:p>
+            <a:pPr algn="ctr"/>
+            <a:r>
+              <a:rPr sz="900" b="1" i="0">
+                <a:solidFill>
+                  <a:srgbClr val="404040"/>
+                </a:solidFill>
+                <a:latin typeface="Segoe UI"/>
+              </a:rPr>
+              <a:t>Ruled in Beem's favor?</a:t>
+            </a:r>
+          </a:p>
+        </p:txBody>
+      </p:sp>
+      <p:sp>
+        <p:nvSpPr>
+          <p:cNvPr id="976" name="Rounded Rectangle 975"/>
+          <p:cNvSpPr/>
+          <p:nvPr/>
+        </p:nvSpPr>
+        <p:spPr>
+          <a:xfrm>
+            <a:off x="3756000" y="2500000"/>
+            <a:ext cx="1260000" cy="720000"/>
+          </a:xfrm>
+          <a:prstGeom prst="roundRect">
+            <a:avLst>
+              <a:gd name="adj" fmla="val 10000"/>
+            </a:avLst>
+          </a:prstGeom>
+          <a:noFill/>
+          <a:ln w="12700">
+            <a:solidFill>
+              <a:srgbClr val="BFBFBF"/>
+            </a:solidFill>
+          </a:ln>
+          <a:effectLst/>
+        </p:spPr>
+        <p:style>
+          <a:lnRef idx="1">
+            <a:schemeClr val="accent1"/>
+          </a:lnRef>
+          <a:fillRef idx="3">
+            <a:schemeClr val="accent1"/>
+          </a:fillRef>
+          <a:effectRef idx="2">
+            <a:schemeClr val="accent1"/>
+          </a:effectRef>
+          <a:fontRef idx="minor">
+            <a:schemeClr val="lt1"/>
+          </a:fontRef>
+        </p:style>
+        <p:txBody>
+          <a:bodyPr rtlCol="0" anchor="ctr" wrap="square" lIns="45720" rIns="45720" tIns="36576" bIns="36576"/>
+          <a:lstStyle/>
+          <a:p>
+            <a:pPr algn="ctr"/>
+            <a:r>
+              <a:rPr sz="900" b="1" i="0">
+                <a:solidFill>
+                  <a:srgbClr val="404040"/>
+                </a:solidFill>
+                <a:latin typeface="Segoe UI"/>
+              </a:rPr>
+              <a:t>Finalize or reverse the provisional credit, as applicable</a:t>
+            </a:r>
+          </a:p>
+        </p:txBody>
+      </p:sp>
+      <p:sp>
+        <p:nvSpPr>
+          <p:cNvPr id="977" name="TextBox 976"/>
+          <p:cNvSpPr txBox="1"/>
+          <p:nvPr/>
+        </p:nvSpPr>
+        <p:spPr>
+          <a:xfrm>
+            <a:off x="3716000" y="3260000"/>
+            <a:ext cx="1340000" cy="430000"/>
+          </a:xfrm>
+          <a:prstGeom prst="rect">
+            <a:avLst/>
+          </a:prstGeom>
+          <a:noFill/>
+        </p:spPr>
+        <p:txBody>
+          <a:bodyPr wrap="square" lIns="45720" rIns="45720" tIns="36576" bIns="36576" anchor="ctr">
+            <a:spAutoFit/>
+          </a:bodyPr>
+          <a:lstStyle/>
+          <a:p>
+            <a:pPr algn="ctr"/>
+            <a:r>
+              <a:rPr sz="700" b="0" i="1">
+                <a:solidFill>
+                  <a:srgbClr val="404040"/>
+                </a:solidFill>
+                <a:latin typeface="Segoe UI"/>
+              </a:rPr>
+              <a:t>Retain credit if ruled in Beem's favor; reverse if ruled against Beem</a:t>
+            </a:r>
+          </a:p>
+        </p:txBody>
+      </p:sp>
+      <p:sp>
+        <p:nvSpPr>
+          <p:cNvPr id="978" name="Rounded Rectangle 977"/>
+          <p:cNvSpPr/>
+          <p:nvPr/>
+        </p:nvSpPr>
+        <p:spPr>
+          <a:xfrm>
+            <a:off x="5316000" y="2500000"/>
+            <a:ext cx="1260000" cy="720000"/>
+          </a:xfrm>
+          <a:prstGeom prst="roundRect">
+            <a:avLst>
+              <a:gd name="adj" fmla="val 10000"/>
+            </a:avLst>
+          </a:prstGeom>
+          <a:solidFill>
+            <a:srgbClr val="EDDBFB">
+              <a:alpha val="56863"/>
+            </a:srgbClr>
+          </a:solidFill>
+          <a:ln w="12700">
+            <a:solidFill>
+              <a:srgbClr val="9B40EA"/>
+            </a:solidFill>
+          </a:ln>
+          <a:effectLst/>
+        </p:spPr>
+        <p:style>
+          <a:lnRef idx="1">
+            <a:schemeClr val="accent1"/>
+          </a:lnRef>
+          <a:fillRef idx="3">
+            <a:schemeClr val="accent1"/>
+          </a:fillRef>
+          <a:effectRef idx="2">
+            <a:schemeClr val="accent1"/>
+          </a:effectRef>
+          <a:fontRef idx="minor">
+            <a:schemeClr val="lt1"/>
+          </a:fontRef>
+        </p:style>
+        <p:txBody>
+          <a:bodyPr rtlCol="0" anchor="ctr" wrap="square" lIns="45720" rIns="45720" tIns="36576" bIns="36576"/>
+          <a:lstStyle/>
+          <a:p>
+            <a:pPr algn="ctr"/>
+            <a:r>
+              <a:rPr sz="900" b="1" i="0">
+                <a:solidFill>
+                  <a:srgbClr val="404040"/>
+                </a:solidFill>
+                <a:latin typeface="Segoe UI"/>
+              </a:rPr>
+              <a:t>Notify cardholder of the decision</a:t>
+            </a:r>
+          </a:p>
+        </p:txBody>
+      </p:sp>
+      <p:sp>
+        <p:nvSpPr>
+          <p:cNvPr id="979" name="Rounded Rectangle 978"/>
+          <p:cNvSpPr/>
+          <p:nvPr/>
+        </p:nvSpPr>
+        <p:spPr>
+          <a:xfrm>
+            <a:off x="6876000" y="2500000"/>
+            <a:ext cx="1260000" cy="720000"/>
+          </a:xfrm>
+          <a:prstGeom prst="roundRect">
+            <a:avLst>
+              <a:gd name="adj" fmla="val 10000"/>
+            </a:avLst>
+          </a:prstGeom>
+          <a:noFill/>
+          <a:ln w="12700">
+            <a:solidFill>
+              <a:srgbClr val="BFBFBF"/>
+            </a:solidFill>
+          </a:ln>
+          <a:effectLst/>
+        </p:spPr>
+        <p:style>
+          <a:lnRef idx="1">
+            <a:schemeClr val="accent1"/>
+          </a:lnRef>
+          <a:fillRef idx="3">
+            <a:schemeClr val="accent1"/>
+          </a:fillRef>
+          <a:effectRef idx="2">
+            <a:schemeClr val="accent1"/>
+          </a:effectRef>
+          <a:fontRef idx="minor">
+            <a:schemeClr val="lt1"/>
+          </a:fontRef>
+        </p:style>
+        <p:txBody>
+          <a:bodyPr rtlCol="0" anchor="ctr" wrap="square" lIns="45720" rIns="45720" tIns="36576" bIns="36576"/>
+          <a:lstStyle/>
+          <a:p>
+            <a:pPr algn="ctr"/>
+            <a:r>
+              <a:rPr sz="900" b="1" i="0">
+                <a:solidFill>
+                  <a:srgbClr val="404040"/>
+                </a:solidFill>
+                <a:latin typeface="Segoe UI"/>
+              </a:rPr>
+              <a:t>Record recoveries, losses, fees &amp; GL entries</a:t>
+            </a:r>
+          </a:p>
+        </p:txBody>
+      </p:sp>
+      <p:sp>
+        <p:nvSpPr>
+          <p:cNvPr id="980" name="Rounded Rectangle 979"/>
+          <p:cNvSpPr/>
+          <p:nvPr/>
+        </p:nvSpPr>
+        <p:spPr>
+          <a:xfrm>
+            <a:off x="8436000" y="2500000"/>
+            <a:ext cx="1260000" cy="720000"/>
+          </a:xfrm>
+          <a:prstGeom prst="roundRect">
+            <a:avLst>
+              <a:gd name="adj" fmla="val 10000"/>
+            </a:avLst>
+          </a:prstGeom>
+          <a:noFill/>
+          <a:ln w="12700">
+            <a:solidFill>
+              <a:srgbClr val="BFBFBF"/>
+            </a:solidFill>
+          </a:ln>
+          <a:effectLst/>
+        </p:spPr>
+        <p:style>
+          <a:lnRef idx="1">
+            <a:schemeClr val="accent1"/>
+          </a:lnRef>
+          <a:fillRef idx="3">
+            <a:schemeClr val="accent1"/>
+          </a:fillRef>
+          <a:effectRef idx="2">
+            <a:schemeClr val="accent1"/>
+          </a:effectRef>
+          <a:fontRef idx="minor">
+            <a:schemeClr val="lt1"/>
+          </a:fontRef>
+        </p:style>
+        <p:txBody>
+          <a:bodyPr rtlCol="0" anchor="ctr" wrap="square" lIns="45720" rIns="45720" tIns="36576" bIns="36576"/>
+          <a:lstStyle/>
+          <a:p>
+            <a:pPr algn="ctr"/>
+            <a:r>
+              <a:rPr sz="900" b="1" i="0">
+                <a:solidFill>
+                  <a:srgbClr val="404040"/>
+                </a:solidFill>
+                <a:latin typeface="Segoe UI"/>
+              </a:rPr>
+              <a:t>Archive supporting evidence &amp; close case</a:t>
+            </a:r>
+          </a:p>
+        </p:txBody>
+      </p:sp>
+      <p:sp>
+        <p:nvSpPr>
+          <p:cNvPr id="981" name="Rounded Rectangle 980"/>
+          <p:cNvSpPr/>
+          <p:nvPr/>
+        </p:nvSpPr>
+        <p:spPr>
+          <a:xfrm>
+            <a:off x="9996000" y="2500000"/>
+            <a:ext cx="1260000" cy="720000"/>
+          </a:xfrm>
+          <a:prstGeom prst="roundRect">
+            <a:avLst>
+              <a:gd name="adj" fmla="val 10000"/>
+            </a:avLst>
+          </a:prstGeom>
+          <a:noFill/>
+          <a:ln w="12700">
+            <a:solidFill>
+              <a:srgbClr val="BFBFBF"/>
+            </a:solidFill>
+          </a:ln>
+          <a:effectLst/>
+        </p:spPr>
+        <p:style>
+          <a:lnRef idx="1">
+            <a:schemeClr val="accent1"/>
+          </a:lnRef>
+          <a:fillRef idx="3">
+            <a:schemeClr val="accent1"/>
+          </a:fillRef>
+          <a:effectRef idx="2">
+            <a:schemeClr val="accent1"/>
+          </a:effectRef>
+          <a:fontRef idx="minor">
+            <a:schemeClr val="lt1"/>
+          </a:fontRef>
+        </p:style>
+        <p:txBody>
+          <a:bodyPr rtlCol="0" anchor="ctr" wrap="square" lIns="45720" rIns="45720" tIns="36576" bIns="36576"/>
+          <a:lstStyle/>
+          <a:p>
+            <a:pPr algn="ctr"/>
+            <a:r>
+              <a:rPr sz="900" b="1" i="0">
+                <a:solidFill>
+                  <a:srgbClr val="404040"/>
+                </a:solidFill>
+                <a:latin typeface="Segoe UI"/>
+              </a:rPr>
+              <a:t>Prepare reporting &amp; trend analysis</a:t>
+            </a:r>
+          </a:p>
+        </p:txBody>
+      </p:sp>
+      <p:cxnSp>
+        <p:nvCxnSpPr>
+          <p:cNvPr id="982" name="Connector 981"/>
+          <p:cNvCxnSpPr/>
+          <p:nvPr/>
+        </p:nvCxnSpPr>
+        <p:spPr>
+          <a:xfrm>
+            <a:off x="1560000" y="2860000"/>
+            <a:ext cx="450000" cy="0"/>
+          </a:xfrm>
+          <a:prstGeom prst="line">
+            <a:avLst/>
+          </a:prstGeom>
+          <a:ln w="19050">
+            <a:solidFill>
+              <a:srgbClr val="9B9B9B"/>
+            </a:solidFill>
+            <a:tailEnd type="triangle" w="med" len="med"/>
+          </a:ln>
+        </p:spPr>
+        <p:style>
+          <a:lnRef idx="2">
+            <a:schemeClr val="accent1"/>
+          </a:lnRef>
+          <a:fillRef idx="0">
+            <a:schemeClr val="accent1"/>
+          </a:fillRef>
+          <a:effectRef idx="1">
+            <a:schemeClr val="accent1"/>
+          </a:effectRef>
+          <a:fontRef idx="minor">
+            <a:schemeClr val="tx1"/>
+          </a:fontRef>
+        </p:style>
+      </p:cxnSp>
+      <p:cxnSp>
+        <p:nvCxnSpPr>
+          <p:cNvPr id="983" name="Connector 982"/>
+          <p:cNvCxnSpPr/>
+          <p:nvPr/>
+        </p:nvCxnSpPr>
+        <p:spPr>
+          <a:xfrm>
+            <a:off x="3306000" y="2770000"/>
+            <a:ext cx="450000" cy="0"/>
+          </a:xfrm>
+          <a:prstGeom prst="line">
+            <a:avLst/>
+          </a:prstGeom>
+          <a:ln w="19050">
+            <a:solidFill>
+              <a:srgbClr val="9B9B9B"/>
+            </a:solidFill>
+            <a:tailEnd type="triangle" w="med" len="med"/>
+          </a:ln>
+        </p:spPr>
+        <p:style>
+          <a:lnRef idx="2">
+            <a:schemeClr val="accent1"/>
+          </a:lnRef>
+          <a:fillRef idx="0">
+            <a:schemeClr val="accent1"/>
+          </a:fillRef>
+          <a:effectRef idx="1">
+            <a:schemeClr val="accent1"/>
+          </a:effectRef>
+          <a:fontRef idx="minor">
+            <a:schemeClr val="tx1"/>
+          </a:fontRef>
+        </p:style>
+      </p:cxnSp>
+      <p:sp>
+        <p:nvSpPr>
+          <p:cNvPr id="984" name="TextBox 983"/>
+          <p:cNvSpPr txBox="1"/>
+          <p:nvPr/>
+        </p:nvSpPr>
+        <p:spPr>
+          <a:xfrm>
+            <a:off x="3046000" y="2480000"/>
+            <a:ext cx="620000" cy="260000"/>
+          </a:xfrm>
+          <a:prstGeom prst="rect">
+            <a:avLst/>
+          </a:prstGeom>
+          <a:noFill/>
+        </p:spPr>
+        <p:txBody>
+          <a:bodyPr wrap="square" lIns="45720" rIns="45720" tIns="36576" bIns="36576" anchor="ctr">
+            <a:spAutoFit/>
+          </a:bodyPr>
+          <a:lstStyle/>
+          <a:p>
+            <a:pPr algn="ctr"/>
+            <a:r>
+              <a:rPr sz="900" b="1" i="0">
+                <a:solidFill>
+                  <a:srgbClr val="009A44"/>
+                </a:solidFill>
+                <a:latin typeface="Segoe UI"/>
+              </a:rPr>
+              <a:t>Yes</a:t>
+            </a:r>
+          </a:p>
+        </p:txBody>
+      </p:sp>
+      <p:cxnSp>
+        <p:nvCxnSpPr>
+          <p:cNvPr id="985" name="Connector 984"/>
+          <p:cNvCxnSpPr/>
+          <p:nvPr/>
+        </p:nvCxnSpPr>
+        <p:spPr>
+          <a:xfrm flipV="1">
+            <a:off x="2658000" y="3220000"/>
+            <a:ext cx="1728000" cy="74340"/>
+          </a:xfrm>
+          <a:prstGeom prst="bentConnector3">
+            <a:avLst/>
+          </a:prstGeom>
+          <a:ln w="19050">
+            <a:solidFill>
+              <a:srgbClr val="9B9B9B"/>
+            </a:solidFill>
+            <a:tailEnd type="triangle" w="med" len="med"/>
+          </a:ln>
+        </p:spPr>
+        <p:style>
+          <a:lnRef idx="2">
+            <a:schemeClr val="accent1"/>
+          </a:lnRef>
+          <a:fillRef idx="0">
+            <a:schemeClr val="accent1"/>
+          </a:fillRef>
+          <a:effectRef idx="1">
+            <a:schemeClr val="accent1"/>
+          </a:effectRef>
+          <a:fontRef idx="minor">
+            <a:schemeClr val="tx1"/>
+          </a:fontRef>
+        </p:style>
+      </p:cxnSp>
+      <p:sp>
+        <p:nvSpPr>
+          <p:cNvPr id="986" name="TextBox 985"/>
+          <p:cNvSpPr txBox="1"/>
+          <p:nvPr/>
+        </p:nvSpPr>
+        <p:spPr>
+          <a:xfrm>
+            <a:off x="2698000" y="3324340"/>
+            <a:ext cx="620000" cy="260000"/>
+          </a:xfrm>
+          <a:prstGeom prst="rect">
+            <a:avLst/>
+          </a:prstGeom>
+          <a:noFill/>
+        </p:spPr>
+        <p:txBody>
+          <a:bodyPr wrap="square" lIns="45720" rIns="45720" tIns="36576" bIns="36576" anchor="ctr">
+            <a:spAutoFit/>
+          </a:bodyPr>
+          <a:lstStyle/>
+          <a:p>
+            <a:pPr algn="ctr"/>
+            <a:r>
+              <a:rPr sz="900" b="1" i="0">
+                <a:solidFill>
+                  <a:srgbClr val="C00000"/>
+                </a:solidFill>
+                <a:latin typeface="Segoe UI"/>
+              </a:rPr>
+              <a:t>No</a:t>
+            </a:r>
+          </a:p>
+        </p:txBody>
+      </p:sp>
+      <p:cxnSp>
+        <p:nvCxnSpPr>
+          <p:cNvPr id="987" name="Connector 986"/>
+          <p:cNvCxnSpPr/>
+          <p:nvPr/>
+        </p:nvCxnSpPr>
+        <p:spPr>
+          <a:xfrm>
+            <a:off x="5016000" y="2860000"/>
+            <a:ext cx="300000" cy="0"/>
+          </a:xfrm>
+          <a:prstGeom prst="line">
+            <a:avLst/>
+          </a:prstGeom>
+          <a:ln w="19050">
+            <a:solidFill>
+              <a:srgbClr val="9B9B9B"/>
+            </a:solidFill>
+            <a:tailEnd type="triangle" w="med" len="med"/>
+          </a:ln>
+        </p:spPr>
+        <p:style>
+          <a:lnRef idx="2">
+            <a:schemeClr val="accent1"/>
+          </a:lnRef>
+          <a:fillRef idx="0">
+            <a:schemeClr val="accent1"/>
+          </a:fillRef>
+          <a:effectRef idx="1">
+            <a:schemeClr val="accent1"/>
+          </a:effectRef>
+          <a:fontRef idx="minor">
+            <a:schemeClr val="tx1"/>
+          </a:fontRef>
+        </p:style>
+      </p:cxnSp>
+      <p:cxnSp>
+        <p:nvCxnSpPr>
+          <p:cNvPr id="988" name="Connector 987"/>
+          <p:cNvCxnSpPr/>
+          <p:nvPr/>
+        </p:nvCxnSpPr>
+        <p:spPr>
+          <a:xfrm>
+            <a:off x="6576000" y="2860000"/>
+            <a:ext cx="300000" cy="0"/>
+          </a:xfrm>
+          <a:prstGeom prst="line">
+            <a:avLst/>
+          </a:prstGeom>
+          <a:ln w="19050">
+            <a:solidFill>
+              <a:srgbClr val="9B9B9B"/>
+            </a:solidFill>
+            <a:tailEnd type="triangle" w="med" len="med"/>
+          </a:ln>
+        </p:spPr>
+        <p:style>
+          <a:lnRef idx="2">
+            <a:schemeClr val="accent1"/>
+          </a:lnRef>
+          <a:fillRef idx="0">
+            <a:schemeClr val="accent1"/>
+          </a:fillRef>
+          <a:effectRef idx="1">
+            <a:schemeClr val="accent1"/>
+          </a:effectRef>
+          <a:fontRef idx="minor">
+            <a:schemeClr val="tx1"/>
+          </a:fontRef>
+        </p:style>
+      </p:cxnSp>
+      <p:cxnSp>
+        <p:nvCxnSpPr>
+          <p:cNvPr id="989" name="Connector 988"/>
+          <p:cNvCxnSpPr/>
+          <p:nvPr/>
+        </p:nvCxnSpPr>
+        <p:spPr>
+          <a:xfrm>
+            <a:off x="8136000" y="2860000"/>
+            <a:ext cx="300000" cy="0"/>
+          </a:xfrm>
+          <a:prstGeom prst="line">
+            <a:avLst/>
+          </a:prstGeom>
+          <a:ln w="19050">
+            <a:solidFill>
+              <a:srgbClr val="9B9B9B"/>
+            </a:solidFill>
+            <a:tailEnd type="triangle" w="med" len="med"/>
+          </a:ln>
+        </p:spPr>
+        <p:style>
+          <a:lnRef idx="2">
+            <a:schemeClr val="accent1"/>
+          </a:lnRef>
+          <a:fillRef idx="0">
+            <a:schemeClr val="accent1"/>
+          </a:fillRef>
+          <a:effectRef idx="1">
+            <a:schemeClr val="accent1"/>
+          </a:effectRef>
+          <a:fontRef idx="minor">
+            <a:schemeClr val="tx1"/>
+          </a:fontRef>
+        </p:style>
+      </p:cxnSp>
+      <p:cxnSp>
+        <p:nvCxnSpPr>
+          <p:cNvPr id="990" name="Connector 989"/>
+          <p:cNvCxnSpPr/>
+          <p:nvPr/>
+        </p:nvCxnSpPr>
+        <p:spPr>
+          <a:xfrm>
+            <a:off x="9696000" y="2860000"/>
+            <a:ext cx="300000" cy="0"/>
+          </a:xfrm>
+          <a:prstGeom prst="line">
+            <a:avLst/>
+          </a:prstGeom>
+          <a:ln w="19050">
+            <a:solidFill>
+              <a:srgbClr val="9B9B9B"/>
+            </a:solidFill>
+            <a:tailEnd type="triangle" w="med" len="med"/>
+          </a:ln>
+        </p:spPr>
+        <p:style>
+          <a:lnRef idx="2">
+            <a:schemeClr val="accent1"/>
+          </a:lnRef>
+          <a:fillRef idx="0">
+            <a:schemeClr val="accent1"/>
+          </a:fillRef>
+          <a:effectRef idx="1">
+            <a:schemeClr val="accent1"/>
+          </a:effectRef>
+          <a:fontRef idx="minor">
+            <a:schemeClr val="tx1"/>
+          </a:fontRef>
+        </p:style>
+      </p:cxnSp>
     </p:spTree>
     <p:extLst>
       <p:ext uri="{BB962C8B-B14F-4D97-AF65-F5344CB8AC3E}">

</xml_diff>